<commit_message>
added lectures 13 and 14
</commit_message>
<xml_diff>
--- a/ECE1390_Lecture13.pptx
+++ b/ECE1390_Lecture13.pptx
@@ -214,7 +214,7 @@
           <a:p>
             <a:fld id="{84B0C249-CFF4-8549-9C1D-83533EF6B8ED}" type="datetimeFigureOut">
               <a:rPr lang="en-US" smtClean="0"/>
-              <a:t>10/14/24</a:t>
+              <a:t>10/16/24</a:t>
             </a:fld>
             <a:endParaRPr lang="en-US"/>
           </a:p>
@@ -880,7 +880,7 @@
           <a:p>
             <a:fld id="{13E9B49C-C8FD-4344-8CD3-ED4C91409D68}" type="datetimeFigureOut">
               <a:rPr lang="en-US" smtClean="0"/>
-              <a:t>10/14/24</a:t>
+              <a:t>10/16/24</a:t>
             </a:fld>
             <a:endParaRPr lang="en-US"/>
           </a:p>
@@ -1078,7 +1078,7 @@
           <a:p>
             <a:fld id="{13E9B49C-C8FD-4344-8CD3-ED4C91409D68}" type="datetimeFigureOut">
               <a:rPr lang="en-US" smtClean="0"/>
-              <a:t>10/14/24</a:t>
+              <a:t>10/16/24</a:t>
             </a:fld>
             <a:endParaRPr lang="en-US"/>
           </a:p>
@@ -1286,7 +1286,7 @@
           <a:p>
             <a:fld id="{13E9B49C-C8FD-4344-8CD3-ED4C91409D68}" type="datetimeFigureOut">
               <a:rPr lang="en-US" smtClean="0"/>
-              <a:t>10/14/24</a:t>
+              <a:t>10/16/24</a:t>
             </a:fld>
             <a:endParaRPr lang="en-US"/>
           </a:p>
@@ -1484,7 +1484,7 @@
           <a:p>
             <a:fld id="{13E9B49C-C8FD-4344-8CD3-ED4C91409D68}" type="datetimeFigureOut">
               <a:rPr lang="en-US" smtClean="0"/>
-              <a:t>10/14/24</a:t>
+              <a:t>10/16/24</a:t>
             </a:fld>
             <a:endParaRPr lang="en-US"/>
           </a:p>
@@ -1759,7 +1759,7 @@
           <a:p>
             <a:fld id="{13E9B49C-C8FD-4344-8CD3-ED4C91409D68}" type="datetimeFigureOut">
               <a:rPr lang="en-US" smtClean="0"/>
-              <a:t>10/14/24</a:t>
+              <a:t>10/16/24</a:t>
             </a:fld>
             <a:endParaRPr lang="en-US"/>
           </a:p>
@@ -2024,7 +2024,7 @@
           <a:p>
             <a:fld id="{13E9B49C-C8FD-4344-8CD3-ED4C91409D68}" type="datetimeFigureOut">
               <a:rPr lang="en-US" smtClean="0"/>
-              <a:t>10/14/24</a:t>
+              <a:t>10/16/24</a:t>
             </a:fld>
             <a:endParaRPr lang="en-US"/>
           </a:p>
@@ -2436,7 +2436,7 @@
           <a:p>
             <a:fld id="{13E9B49C-C8FD-4344-8CD3-ED4C91409D68}" type="datetimeFigureOut">
               <a:rPr lang="en-US" smtClean="0"/>
-              <a:t>10/14/24</a:t>
+              <a:t>10/16/24</a:t>
             </a:fld>
             <a:endParaRPr lang="en-US"/>
           </a:p>
@@ -2577,7 +2577,7 @@
           <a:p>
             <a:fld id="{13E9B49C-C8FD-4344-8CD3-ED4C91409D68}" type="datetimeFigureOut">
               <a:rPr lang="en-US" smtClean="0"/>
-              <a:t>10/14/24</a:t>
+              <a:t>10/16/24</a:t>
             </a:fld>
             <a:endParaRPr lang="en-US"/>
           </a:p>
@@ -2690,7 +2690,7 @@
           <a:p>
             <a:fld id="{13E9B49C-C8FD-4344-8CD3-ED4C91409D68}" type="datetimeFigureOut">
               <a:rPr lang="en-US" smtClean="0"/>
-              <a:t>10/14/24</a:t>
+              <a:t>10/16/24</a:t>
             </a:fld>
             <a:endParaRPr lang="en-US"/>
           </a:p>
@@ -3001,7 +3001,7 @@
           <a:p>
             <a:fld id="{13E9B49C-C8FD-4344-8CD3-ED4C91409D68}" type="datetimeFigureOut">
               <a:rPr lang="en-US" smtClean="0"/>
-              <a:t>10/14/24</a:t>
+              <a:t>10/16/24</a:t>
             </a:fld>
             <a:endParaRPr lang="en-US"/>
           </a:p>
@@ -3289,7 +3289,7 @@
           <a:p>
             <a:fld id="{13E9B49C-C8FD-4344-8CD3-ED4C91409D68}" type="datetimeFigureOut">
               <a:rPr lang="en-US" smtClean="0"/>
-              <a:t>10/14/24</a:t>
+              <a:t>10/16/24</a:t>
             </a:fld>
             <a:endParaRPr lang="en-US"/>
           </a:p>
@@ -3530,7 +3530,7 @@
           <a:p>
             <a:fld id="{13E9B49C-C8FD-4344-8CD3-ED4C91409D68}" type="datetimeFigureOut">
               <a:rPr lang="en-US" smtClean="0"/>
-              <a:t>10/14/24</a:t>
+              <a:t>10/16/24</a:t>
             </a:fld>
             <a:endParaRPr lang="en-US"/>
           </a:p>
@@ -5336,8 +5336,8 @@
           </a:p>
         </p:txBody>
       </p:sp>
-      <mc:AlternateContent xmlns:mc="http://schemas.openxmlformats.org/markup-compatibility/2006">
-        <mc:Choice xmlns:a14="http://schemas.microsoft.com/office/drawing/2010/main" Requires="a14">
+      <mc:AlternateContent xmlns:mc="http://schemas.openxmlformats.org/markup-compatibility/2006" xmlns:a14="http://schemas.microsoft.com/office/drawing/2010/main">
+        <mc:Choice Requires="a14">
           <p:sp>
             <p:nvSpPr>
               <p:cNvPr id="6" name="TextBox 5">
@@ -5366,6 +5366,7 @@
               </a:bodyPr>
               <a:lstStyle/>
               <a:p>
+                <a:pPr/>
                 <a14:m>
                   <m:oMathPara xmlns:m="http://schemas.openxmlformats.org/officeDocument/2006/math">
                     <m:oMathParaPr>
@@ -5672,7 +5673,7 @@
             </p:txBody>
           </p:sp>
         </mc:Choice>
-        <mc:Fallback>
+        <mc:Fallback xmlns="">
           <p:sp>
             <p:nvSpPr>
               <p:cNvPr id="6" name="TextBox 5">
@@ -8707,8 +8708,8 @@
           </a:p>
         </p:txBody>
       </p:sp>
-      <mc:AlternateContent xmlns:mc="http://schemas.openxmlformats.org/markup-compatibility/2006">
-        <mc:Choice xmlns:a14="http://schemas.microsoft.com/office/drawing/2010/main" Requires="a14">
+      <mc:AlternateContent xmlns:mc="http://schemas.openxmlformats.org/markup-compatibility/2006" xmlns:a14="http://schemas.microsoft.com/office/drawing/2010/main">
+        <mc:Choice Requires="a14">
           <p:sp>
             <p:nvSpPr>
               <p:cNvPr id="8215" name="TextBox 8214">
@@ -8737,6 +8738,7 @@
               </a:bodyPr>
               <a:lstStyle/>
               <a:p>
+                <a:pPr/>
                 <a14:m>
                   <m:oMathPara xmlns:m="http://schemas.openxmlformats.org/officeDocument/2006/math">
                     <m:oMathParaPr>
@@ -9025,7 +9027,7 @@
             </p:txBody>
           </p:sp>
         </mc:Choice>
-        <mc:Fallback>
+        <mc:Fallback xmlns="">
           <p:sp>
             <p:nvSpPr>
               <p:cNvPr id="8215" name="TextBox 8214">
@@ -9233,8 +9235,8 @@
           </a:p>
         </p:txBody>
       </p:sp>
-      <mc:AlternateContent xmlns:mc="http://schemas.openxmlformats.org/markup-compatibility/2006">
-        <mc:Choice xmlns:a14="http://schemas.microsoft.com/office/drawing/2010/main" Requires="a14">
+      <mc:AlternateContent xmlns:mc="http://schemas.openxmlformats.org/markup-compatibility/2006" xmlns:a14="http://schemas.microsoft.com/office/drawing/2010/main">
+        <mc:Choice Requires="a14">
           <p:sp>
             <p:nvSpPr>
               <p:cNvPr id="5" name="TextBox 4">
@@ -9263,6 +9265,7 @@
               </a:bodyPr>
               <a:lstStyle/>
               <a:p>
+                <a:pPr/>
                 <a14:m>
                   <m:oMathPara xmlns:m="http://schemas.openxmlformats.org/officeDocument/2006/math">
                     <m:oMathParaPr>
@@ -9474,7 +9477,7 @@
             </p:txBody>
           </p:sp>
         </mc:Choice>
-        <mc:Fallback>
+        <mc:Fallback xmlns="">
           <p:sp>
             <p:nvSpPr>
               <p:cNvPr id="5" name="TextBox 4">
@@ -10678,8 +10681,8 @@
           </p:txBody>
         </p:sp>
       </p:grpSp>
-      <mc:AlternateContent xmlns:mc="http://schemas.openxmlformats.org/markup-compatibility/2006">
-        <mc:Choice xmlns:a14="http://schemas.microsoft.com/office/drawing/2010/main" Requires="a14">
+      <mc:AlternateContent xmlns:mc="http://schemas.openxmlformats.org/markup-compatibility/2006" xmlns:a14="http://schemas.microsoft.com/office/drawing/2010/main">
+        <mc:Choice Requires="a14">
           <p:sp>
             <p:nvSpPr>
               <p:cNvPr id="48" name="TextBox 47">
@@ -10708,6 +10711,7 @@
               </a:bodyPr>
               <a:lstStyle/>
               <a:p>
+                <a:pPr/>
                 <a14:m>
                   <m:oMathPara xmlns:m="http://schemas.openxmlformats.org/officeDocument/2006/math">
                     <m:oMathParaPr>
@@ -10772,7 +10776,16 @@
                                       <a:rPr lang="en-US" b="0" i="0" smtClean="0">
                                         <a:latin typeface="Cambria Math" panose="02040503050406030204" pitchFamily="18" charset="0"/>
                                       </a:rPr>
-                                      <m:t>cos</m:t>
+                                      <m:t>c</m:t>
+                                    </m:r>
+                                    <m:r>
+                                      <m:rPr>
+                                        <m:sty m:val="p"/>
+                                      </m:rPr>
+                                      <a:rPr lang="en-US" b="0" i="0" smtClean="0">
+                                        <a:latin typeface="Cambria Math" panose="02040503050406030204" pitchFamily="18" charset="0"/>
+                                      </a:rPr>
+                                      <m:t>os</m:t>
                                     </m:r>
                                   </m:fName>
                                   <m:e>
@@ -11033,7 +11046,7 @@
             </p:txBody>
           </p:sp>
         </mc:Choice>
-        <mc:Fallback>
+        <mc:Fallback xmlns="">
           <p:sp>
             <p:nvSpPr>
               <p:cNvPr id="48" name="TextBox 47">
@@ -11117,8 +11130,8 @@
           </a:p>
         </p:txBody>
       </p:sp>
-      <mc:AlternateContent xmlns:mc="http://schemas.openxmlformats.org/markup-compatibility/2006">
-        <mc:Choice xmlns:a14="http://schemas.microsoft.com/office/drawing/2010/main" Requires="a14">
+      <mc:AlternateContent xmlns:mc="http://schemas.openxmlformats.org/markup-compatibility/2006" xmlns:a14="http://schemas.microsoft.com/office/drawing/2010/main">
+        <mc:Choice Requires="a14">
           <p:sp>
             <p:nvSpPr>
               <p:cNvPr id="51" name="TextBox 50">
@@ -11147,6 +11160,7 @@
               </a:bodyPr>
               <a:lstStyle/>
               <a:p>
+                <a:pPr/>
                 <a14:m>
                   <m:oMathPara xmlns:m="http://schemas.openxmlformats.org/officeDocument/2006/math">
                     <m:oMathParaPr>
@@ -11211,7 +11225,16 @@
                                       <a:rPr lang="en-US" b="0" i="0" smtClean="0">
                                         <a:latin typeface="Cambria Math" panose="02040503050406030204" pitchFamily="18" charset="0"/>
                                       </a:rPr>
-                                      <m:t>cos</m:t>
+                                      <m:t>c</m:t>
+                                    </m:r>
+                                    <m:r>
+                                      <m:rPr>
+                                        <m:sty m:val="p"/>
+                                      </m:rPr>
+                                      <a:rPr lang="en-US" b="0" i="0" smtClean="0">
+                                        <a:latin typeface="Cambria Math" panose="02040503050406030204" pitchFamily="18" charset="0"/>
+                                      </a:rPr>
+                                      <m:t>os</m:t>
                                     </m:r>
                                   </m:fName>
                                   <m:e>
@@ -11474,7 +11497,7 @@
             </p:txBody>
           </p:sp>
         </mc:Choice>
-        <mc:Fallback>
+        <mc:Fallback xmlns="">
           <p:sp>
             <p:nvSpPr>
               <p:cNvPr id="51" name="TextBox 50">
@@ -11608,8 +11631,8 @@
           </a:p>
         </p:txBody>
       </p:sp>
-      <mc:AlternateContent xmlns:mc="http://schemas.openxmlformats.org/markup-compatibility/2006">
-        <mc:Choice xmlns:a14="http://schemas.microsoft.com/office/drawing/2010/main" Requires="a14">
+      <mc:AlternateContent xmlns:mc="http://schemas.openxmlformats.org/markup-compatibility/2006" xmlns:a14="http://schemas.microsoft.com/office/drawing/2010/main">
+        <mc:Choice Requires="a14">
           <p:sp>
             <p:nvSpPr>
               <p:cNvPr id="54" name="TextBox 53">
@@ -11638,6 +11661,7 @@
               </a:bodyPr>
               <a:lstStyle/>
               <a:p>
+                <a:pPr/>
                 <a14:m>
                   <m:oMathPara xmlns:m="http://schemas.openxmlformats.org/officeDocument/2006/math">
                     <m:oMathParaPr>
@@ -11978,7 +12002,7 @@
             </p:txBody>
           </p:sp>
         </mc:Choice>
-        <mc:Fallback>
+        <mc:Fallback xmlns="">
           <p:sp>
             <p:nvSpPr>
               <p:cNvPr id="54" name="TextBox 53">
@@ -12073,8 +12097,8 @@
           </a:p>
         </p:txBody>
       </p:sp>
-      <mc:AlternateContent xmlns:mc="http://schemas.openxmlformats.org/markup-compatibility/2006">
-        <mc:Choice xmlns:a14="http://schemas.microsoft.com/office/drawing/2010/main" Requires="a14">
+      <mc:AlternateContent xmlns:mc="http://schemas.openxmlformats.org/markup-compatibility/2006" xmlns:a14="http://schemas.microsoft.com/office/drawing/2010/main">
+        <mc:Choice Requires="a14">
           <p:sp>
             <p:nvSpPr>
               <p:cNvPr id="56" name="TextBox 55">
@@ -13671,7 +13695,7 @@
             </p:txBody>
           </p:sp>
         </mc:Choice>
-        <mc:Fallback>
+        <mc:Fallback xmlns="">
           <p:sp>
             <p:nvSpPr>
               <p:cNvPr id="56" name="TextBox 55">
@@ -13827,8 +13851,8 @@
           </a:extLst>
         </p:spPr>
       </p:pic>
-      <mc:AlternateContent xmlns:mc="http://schemas.openxmlformats.org/markup-compatibility/2006">
-        <mc:Choice xmlns:a14="http://schemas.microsoft.com/office/drawing/2010/main" Requires="a14">
+      <mc:AlternateContent xmlns:mc="http://schemas.openxmlformats.org/markup-compatibility/2006" xmlns:a14="http://schemas.microsoft.com/office/drawing/2010/main">
+        <mc:Choice Requires="a14">
           <p:sp>
             <p:nvSpPr>
               <p:cNvPr id="3" name="TextBox 2">
@@ -14551,7 +14575,7 @@
             </p:txBody>
           </p:sp>
         </mc:Choice>
-        <mc:Fallback>
+        <mc:Fallback xmlns="">
           <p:sp>
             <p:nvSpPr>
               <p:cNvPr id="3" name="TextBox 2">
@@ -14596,8 +14620,8 @@
           </p:sp>
         </mc:Fallback>
       </mc:AlternateContent>
-      <mc:AlternateContent xmlns:mc="http://schemas.openxmlformats.org/markup-compatibility/2006">
-        <mc:Choice xmlns:a14="http://schemas.microsoft.com/office/drawing/2010/main" Requires="a14">
+      <mc:AlternateContent xmlns:mc="http://schemas.openxmlformats.org/markup-compatibility/2006" xmlns:a14="http://schemas.microsoft.com/office/drawing/2010/main">
+        <mc:Choice Requires="a14">
           <p:sp>
             <p:nvSpPr>
               <p:cNvPr id="6" name="TextBox 5">
@@ -15007,7 +15031,7 @@
             </p:txBody>
           </p:sp>
         </mc:Choice>
-        <mc:Fallback>
+        <mc:Fallback xmlns="">
           <p:sp>
             <p:nvSpPr>
               <p:cNvPr id="6" name="TextBox 5">
@@ -15087,8 +15111,8 @@
           </a:p>
         </p:txBody>
       </p:sp>
-      <mc:AlternateContent xmlns:mc="http://schemas.openxmlformats.org/markup-compatibility/2006">
-        <mc:Choice xmlns:a14="http://schemas.microsoft.com/office/drawing/2010/main" Requires="a14">
+      <mc:AlternateContent xmlns:mc="http://schemas.openxmlformats.org/markup-compatibility/2006" xmlns:a14="http://schemas.microsoft.com/office/drawing/2010/main">
+        <mc:Choice Requires="a14">
           <p:sp>
             <p:nvSpPr>
               <p:cNvPr id="9" name="TextBox 8">
@@ -15481,7 +15505,7 @@
             </p:txBody>
           </p:sp>
         </mc:Choice>
-        <mc:Fallback>
+        <mc:Fallback xmlns="">
           <p:sp>
             <p:nvSpPr>
               <p:cNvPr id="9" name="TextBox 8">
@@ -15672,8 +15696,8 @@
           </a:extLst>
         </p:spPr>
       </p:pic>
-      <mc:AlternateContent xmlns:mc="http://schemas.openxmlformats.org/markup-compatibility/2006">
-        <mc:Choice xmlns:a14="http://schemas.microsoft.com/office/drawing/2010/main" Requires="a14">
+      <mc:AlternateContent xmlns:mc="http://schemas.openxmlformats.org/markup-compatibility/2006" xmlns:a14="http://schemas.microsoft.com/office/drawing/2010/main">
+        <mc:Choice Requires="a14">
           <p:sp>
             <p:nvSpPr>
               <p:cNvPr id="3" name="TextBox 2">
@@ -16396,7 +16420,7 @@
             </p:txBody>
           </p:sp>
         </mc:Choice>
-        <mc:Fallback>
+        <mc:Fallback xmlns="">
           <p:sp>
             <p:nvSpPr>
               <p:cNvPr id="3" name="TextBox 2">
@@ -16441,8 +16465,8 @@
           </p:sp>
         </mc:Fallback>
       </mc:AlternateContent>
-      <mc:AlternateContent xmlns:mc="http://schemas.openxmlformats.org/markup-compatibility/2006">
-        <mc:Choice xmlns:a14="http://schemas.microsoft.com/office/drawing/2010/main" Requires="a14">
+      <mc:AlternateContent xmlns:mc="http://schemas.openxmlformats.org/markup-compatibility/2006" xmlns:a14="http://schemas.microsoft.com/office/drawing/2010/main">
+        <mc:Choice Requires="a14">
           <p:sp>
             <p:nvSpPr>
               <p:cNvPr id="6" name="TextBox 5">
@@ -16852,7 +16876,7 @@
             </p:txBody>
           </p:sp>
         </mc:Choice>
-        <mc:Fallback>
+        <mc:Fallback xmlns="">
           <p:sp>
             <p:nvSpPr>
               <p:cNvPr id="6" name="TextBox 5">
@@ -16932,8 +16956,8 @@
           </a:p>
         </p:txBody>
       </p:sp>
-      <mc:AlternateContent xmlns:mc="http://schemas.openxmlformats.org/markup-compatibility/2006">
-        <mc:Choice xmlns:a14="http://schemas.microsoft.com/office/drawing/2010/main" Requires="a14">
+      <mc:AlternateContent xmlns:mc="http://schemas.openxmlformats.org/markup-compatibility/2006" xmlns:a14="http://schemas.microsoft.com/office/drawing/2010/main">
+        <mc:Choice Requires="a14">
           <p:sp>
             <p:nvSpPr>
               <p:cNvPr id="9" name="TextBox 8">
@@ -17326,7 +17350,7 @@
             </p:txBody>
           </p:sp>
         </mc:Choice>
-        <mc:Fallback>
+        <mc:Fallback xmlns="">
           <p:sp>
             <p:nvSpPr>
               <p:cNvPr id="9" name="TextBox 8">
@@ -17470,8 +17494,8 @@
           </a:p>
         </p:txBody>
       </p:sp>
-      <mc:AlternateContent xmlns:mc="http://schemas.openxmlformats.org/markup-compatibility/2006">
-        <mc:Choice xmlns:a14="http://schemas.microsoft.com/office/drawing/2010/main" Requires="a14">
+      <mc:AlternateContent xmlns:mc="http://schemas.openxmlformats.org/markup-compatibility/2006" xmlns:a14="http://schemas.microsoft.com/office/drawing/2010/main">
+        <mc:Choice Requires="a14">
           <p:sp>
             <p:nvSpPr>
               <p:cNvPr id="3" name="TextBox 2">
@@ -18194,7 +18218,7 @@
             </p:txBody>
           </p:sp>
         </mc:Choice>
-        <mc:Fallback>
+        <mc:Fallback xmlns="">
           <p:sp>
             <p:nvSpPr>
               <p:cNvPr id="3" name="TextBox 2">
@@ -18239,8 +18263,8 @@
           </p:sp>
         </mc:Fallback>
       </mc:AlternateContent>
-      <mc:AlternateContent xmlns:mc="http://schemas.openxmlformats.org/markup-compatibility/2006">
-        <mc:Choice xmlns:a14="http://schemas.microsoft.com/office/drawing/2010/main" Requires="a14">
+      <mc:AlternateContent xmlns:mc="http://schemas.openxmlformats.org/markup-compatibility/2006" xmlns:a14="http://schemas.microsoft.com/office/drawing/2010/main">
+        <mc:Choice Requires="a14">
           <p:sp>
             <p:nvSpPr>
               <p:cNvPr id="6" name="TextBox 5">
@@ -18650,7 +18674,7 @@
             </p:txBody>
           </p:sp>
         </mc:Choice>
-        <mc:Fallback>
+        <mc:Fallback xmlns="">
           <p:sp>
             <p:nvSpPr>
               <p:cNvPr id="6" name="TextBox 5">
@@ -18730,8 +18754,8 @@
           </a:p>
         </p:txBody>
       </p:sp>
-      <mc:AlternateContent xmlns:mc="http://schemas.openxmlformats.org/markup-compatibility/2006">
-        <mc:Choice xmlns:a14="http://schemas.microsoft.com/office/drawing/2010/main" Requires="a14">
+      <mc:AlternateContent xmlns:mc="http://schemas.openxmlformats.org/markup-compatibility/2006" xmlns:a14="http://schemas.microsoft.com/office/drawing/2010/main">
+        <mc:Choice Requires="a14">
           <p:sp>
             <p:nvSpPr>
               <p:cNvPr id="9" name="TextBox 8">
@@ -19124,7 +19148,7 @@
             </p:txBody>
           </p:sp>
         </mc:Choice>
-        <mc:Fallback>
+        <mc:Fallback xmlns="">
           <p:sp>
             <p:nvSpPr>
               <p:cNvPr id="9" name="TextBox 8">
@@ -19326,8 +19350,8 @@
           </a:prstGeom>
         </p:spPr>
       </p:pic>
-      <mc:AlternateContent xmlns:mc="http://schemas.openxmlformats.org/markup-compatibility/2006">
-        <mc:Choice xmlns:a14="http://schemas.microsoft.com/office/drawing/2010/main" Requires="a14">
+      <mc:AlternateContent xmlns:mc="http://schemas.openxmlformats.org/markup-compatibility/2006" xmlns:a14="http://schemas.microsoft.com/office/drawing/2010/main">
+        <mc:Choice Requires="a14">
           <p:sp>
             <p:nvSpPr>
               <p:cNvPr id="12" name="TextBox 11">
@@ -19479,7 +19503,7 @@
             </p:txBody>
           </p:sp>
         </mc:Choice>
-        <mc:Fallback>
+        <mc:Fallback xmlns="">
           <p:sp>
             <p:nvSpPr>
               <p:cNvPr id="12" name="TextBox 11">
@@ -19524,8 +19548,8 @@
           </p:sp>
         </mc:Fallback>
       </mc:AlternateContent>
-      <mc:AlternateContent xmlns:mc="http://schemas.openxmlformats.org/markup-compatibility/2006">
-        <mc:Choice xmlns:a14="http://schemas.microsoft.com/office/drawing/2010/main" Requires="a14">
+      <mc:AlternateContent xmlns:mc="http://schemas.openxmlformats.org/markup-compatibility/2006" xmlns:a14="http://schemas.microsoft.com/office/drawing/2010/main">
+        <mc:Choice Requires="a14">
           <p:sp>
             <p:nvSpPr>
               <p:cNvPr id="14" name="TextBox 13">
@@ -19629,7 +19653,7 @@
             </p:txBody>
           </p:sp>
         </mc:Choice>
-        <mc:Fallback>
+        <mc:Fallback xmlns="">
           <p:sp>
             <p:nvSpPr>
               <p:cNvPr id="14" name="TextBox 13">
@@ -21288,14 +21312,14 @@
           <p:nvPr>
             <p:extLst>
               <p:ext uri="{D42A27DB-BD31-4B8C-83A1-F6EECF244321}">
-                <p14:modId xmlns:p14="http://schemas.microsoft.com/office/powerpoint/2010/main" val="1574387834"/>
+                <p14:modId xmlns:p14="http://schemas.microsoft.com/office/powerpoint/2010/main" val="626336629"/>
               </p:ext>
             </p:extLst>
           </p:nvPr>
         </p:nvGraphicFramePr>
         <p:xfrm>
-          <a:off x="441434" y="1608908"/>
-          <a:ext cx="11062421" cy="5105124"/>
+          <a:off x="564789" y="1202508"/>
+          <a:ext cx="11062421" cy="5379444"/>
         </p:xfrm>
         <a:graphic>
           <a:graphicData uri="http://schemas.openxmlformats.org/drawingml/2006/table">
@@ -21708,7 +21732,7 @@
                       <a:r>
                         <a:rPr lang="en-US" sz="1800" dirty="0">
                           <a:solidFill>
-                            <a:srgbClr val="FF0000"/>
+                            <a:schemeClr val="tx1"/>
                           </a:solidFill>
                           <a:effectLst/>
                         </a:rPr>
@@ -21742,7 +21766,7 @@
                       <a:r>
                         <a:rPr lang="en-US" sz="1800" dirty="0">
                           <a:solidFill>
-                            <a:srgbClr val="FF0000"/>
+                            <a:schemeClr val="tx1"/>
                           </a:solidFill>
                           <a:effectLst/>
                         </a:rPr>
@@ -21776,7 +21800,7 @@
                       <a:r>
                         <a:rPr lang="en-US" sz="1800" dirty="0">
                           <a:solidFill>
-                            <a:srgbClr val="FF0000"/>
+                            <a:schemeClr val="tx1"/>
                           </a:solidFill>
                           <a:effectLst/>
                         </a:rPr>
@@ -21810,7 +21834,7 @@
                       <a:r>
                         <a:rPr lang="en-US" sz="1800" dirty="0">
                           <a:solidFill>
-                            <a:srgbClr val="FF0000"/>
+                            <a:schemeClr val="tx1"/>
                           </a:solidFill>
                           <a:effectLst/>
                         </a:rPr>
@@ -21931,7 +21955,7 @@
                         <a:rPr lang="en-US" sz="1800" dirty="0">
                           <a:effectLst/>
                         </a:rPr>
-                        <a:t>Depth &amp; 3D Reconstruction</a:t>
+                        <a:t>Depth estimation</a:t>
                       </a:r>
                     </a:p>
                   </a:txBody>
@@ -22107,7 +22131,7 @@
                         <a:rPr lang="en-US" sz="1800" dirty="0">
                           <a:effectLst/>
                         </a:rPr>
-                        <a:t>Image Compression</a:t>
+                        <a:t>3D Reconstruction and Pose estimation</a:t>
                       </a:r>
                     </a:p>
                   </a:txBody>
@@ -22437,7 +22461,7 @@
                         <a:rPr lang="en-US" sz="1800" dirty="0">
                           <a:effectLst/>
                         </a:rPr>
-                        <a:t>Face Detection</a:t>
+                        <a:t>HOG and Custom Detectors</a:t>
                       </a:r>
                     </a:p>
                   </a:txBody>
@@ -22467,6 +22491,9 @@
                       <a:r>
                         <a:rPr lang="en-US" sz="1800" dirty="0">
                           <a:effectLst/>
+                          <a:highlight>
+                            <a:srgbClr val="FFFF00"/>
+                          </a:highlight>
                         </a:rPr>
                         <a:t>Project updates</a:t>
                       </a:r>
@@ -22566,679 +22593,6 @@
                           <a:effectLst/>
                         </a:rPr>
                         <a:t>11/4/2024</a:t>
-                      </a:r>
-                    </a:p>
-                  </a:txBody>
-                  <a:tcPr marL="4649" marR="4649" marT="4649" marB="4649" anchor="ctr">
-                    <a:lnL>
-                      <a:noFill/>
-                    </a:lnL>
-                    <a:lnR>
-                      <a:noFill/>
-                    </a:lnR>
-                    <a:lnT>
-                      <a:noFill/>
-                    </a:lnT>
-                    <a:lnB>
-                      <a:noFill/>
-                    </a:lnB>
-                    <a:solidFill>
-                      <a:srgbClr val="FFFFFF"/>
-                    </a:solidFill>
-                  </a:tcPr>
-                </a:tc>
-                <a:tc>
-                  <a:txBody>
-                    <a:bodyPr/>
-                    <a:lstStyle/>
-                    <a:p>
-                      <a:r>
-                        <a:rPr lang="en-US" sz="1800" dirty="0">
-                          <a:effectLst/>
-                        </a:rPr>
-                        <a:t>HOG and Custom Detectors</a:t>
-                      </a:r>
-                    </a:p>
-                  </a:txBody>
-                  <a:tcPr marL="4649" marR="4649" marT="4649" marB="4649" anchor="ctr">
-                    <a:lnL>
-                      <a:noFill/>
-                    </a:lnL>
-                    <a:lnR>
-                      <a:noFill/>
-                    </a:lnR>
-                    <a:lnT>
-                      <a:noFill/>
-                    </a:lnT>
-                    <a:lnB>
-                      <a:noFill/>
-                    </a:lnB>
-                    <a:solidFill>
-                      <a:srgbClr val="FFFFFF"/>
-                    </a:solidFill>
-                  </a:tcPr>
-                </a:tc>
-                <a:tc>
-                  <a:txBody>
-                    <a:bodyPr/>
-                    <a:lstStyle/>
-                    <a:p>
-                      <a:r>
-                        <a:rPr lang="en-US" sz="1800" dirty="0">
-                          <a:effectLst/>
-                        </a:rPr>
-                        <a:t>Group Project work</a:t>
-                      </a:r>
-                    </a:p>
-                  </a:txBody>
-                  <a:tcPr marL="4649" marR="4649" marT="4649" marB="4649" anchor="ctr">
-                    <a:lnL>
-                      <a:noFill/>
-                    </a:lnL>
-                    <a:lnR>
-                      <a:noFill/>
-                    </a:lnR>
-                    <a:lnT>
-                      <a:noFill/>
-                    </a:lnT>
-                    <a:lnB>
-                      <a:noFill/>
-                    </a:lnB>
-                    <a:solidFill>
-                      <a:srgbClr val="FFFFFF"/>
-                    </a:solidFill>
-                  </a:tcPr>
-                </a:tc>
-                <a:tc>
-                  <a:txBody>
-                    <a:bodyPr/>
-                    <a:lstStyle/>
-                    <a:p>
-                      <a:endParaRPr lang="en-US" sz="1800" dirty="0">
-                        <a:effectLst/>
-                      </a:endParaRPr>
-                    </a:p>
-                  </a:txBody>
-                  <a:tcPr marL="4649" marR="4649" marT="4649" marB="4649" anchor="ctr">
-                    <a:lnL>
-                      <a:noFill/>
-                    </a:lnL>
-                    <a:lnR>
-                      <a:noFill/>
-                    </a:lnR>
-                    <a:lnT>
-                      <a:noFill/>
-                    </a:lnT>
-                    <a:lnB>
-                      <a:noFill/>
-                    </a:lnB>
-                    <a:solidFill>
-                      <a:srgbClr val="FFFFFF"/>
-                    </a:solidFill>
-                  </a:tcPr>
-                </a:tc>
-                <a:extLst>
-                  <a:ext uri="{0D108BD9-81ED-4DB2-BD59-A6C34878D82A}">
-                    <a16:rowId xmlns:a16="http://schemas.microsoft.com/office/drawing/2014/main" val="3111691061"/>
-                  </a:ext>
-                </a:extLst>
-              </a:tr>
-              <a:tr h="191244">
-                <a:tc>
-                  <a:txBody>
-                    <a:bodyPr/>
-                    <a:lstStyle/>
-                    <a:p>
-                      <a:r>
-                        <a:rPr lang="en-US" sz="1800">
-                          <a:effectLst/>
-                        </a:rPr>
-                        <a:t> </a:t>
-                      </a:r>
-                    </a:p>
-                  </a:txBody>
-                  <a:tcPr marL="4649" marR="4649" marT="4649" marB="4649" anchor="ctr">
-                    <a:lnL>
-                      <a:noFill/>
-                    </a:lnL>
-                    <a:lnR>
-                      <a:noFill/>
-                    </a:lnR>
-                    <a:lnT>
-                      <a:noFill/>
-                    </a:lnT>
-                    <a:lnB>
-                      <a:noFill/>
-                    </a:lnB>
-                    <a:solidFill>
-                      <a:srgbClr val="FFFFFF"/>
-                    </a:solidFill>
-                  </a:tcPr>
-                </a:tc>
-                <a:tc>
-                  <a:txBody>
-                    <a:bodyPr/>
-                    <a:lstStyle/>
-                    <a:p>
-                      <a:r>
-                        <a:rPr lang="en-US" sz="1800">
-                          <a:effectLst/>
-                        </a:rPr>
-                        <a:t>11/6/2024</a:t>
-                      </a:r>
-                    </a:p>
-                  </a:txBody>
-                  <a:tcPr marL="4649" marR="4649" marT="4649" marB="4649" anchor="ctr">
-                    <a:lnL>
-                      <a:noFill/>
-                    </a:lnL>
-                    <a:lnR>
-                      <a:noFill/>
-                    </a:lnR>
-                    <a:lnT>
-                      <a:noFill/>
-                    </a:lnT>
-                    <a:lnB>
-                      <a:noFill/>
-                    </a:lnB>
-                    <a:solidFill>
-                      <a:srgbClr val="FFFFFF"/>
-                    </a:solidFill>
-                  </a:tcPr>
-                </a:tc>
-                <a:tc>
-                  <a:txBody>
-                    <a:bodyPr/>
-                    <a:lstStyle/>
-                    <a:p>
-                      <a:r>
-                        <a:rPr lang="en-US" sz="1800" dirty="0">
-                          <a:effectLst/>
-                        </a:rPr>
-                        <a:t>Object Tracking</a:t>
-                      </a:r>
-                    </a:p>
-                  </a:txBody>
-                  <a:tcPr marL="4649" marR="4649" marT="4649" marB="4649" anchor="ctr">
-                    <a:lnL>
-                      <a:noFill/>
-                    </a:lnL>
-                    <a:lnR>
-                      <a:noFill/>
-                    </a:lnR>
-                    <a:lnT>
-                      <a:noFill/>
-                    </a:lnT>
-                    <a:lnB>
-                      <a:noFill/>
-                    </a:lnB>
-                    <a:solidFill>
-                      <a:srgbClr val="FFFFFF"/>
-                    </a:solidFill>
-                  </a:tcPr>
-                </a:tc>
-                <a:tc>
-                  <a:txBody>
-                    <a:bodyPr/>
-                    <a:lstStyle/>
-                    <a:p>
-                      <a:r>
-                        <a:rPr lang="en-US" sz="1800" dirty="0">
-                          <a:effectLst/>
-                        </a:rPr>
-                        <a:t>Python problems (HW8)</a:t>
-                      </a:r>
-                    </a:p>
-                  </a:txBody>
-                  <a:tcPr marL="4649" marR="4649" marT="4649" marB="4649" anchor="ctr">
-                    <a:lnL>
-                      <a:noFill/>
-                    </a:lnL>
-                    <a:lnR>
-                      <a:noFill/>
-                    </a:lnR>
-                    <a:lnT>
-                      <a:noFill/>
-                    </a:lnT>
-                    <a:lnB>
-                      <a:noFill/>
-                    </a:lnB>
-                    <a:solidFill>
-                      <a:srgbClr val="FFFFFF"/>
-                    </a:solidFill>
-                  </a:tcPr>
-                </a:tc>
-                <a:tc>
-                  <a:txBody>
-                    <a:bodyPr/>
-                    <a:lstStyle/>
-                    <a:p>
-                      <a:r>
-                        <a:rPr lang="en-US" sz="1800" dirty="0">
-                          <a:effectLst/>
-                        </a:rPr>
-                        <a:t>Due 11/13</a:t>
-                      </a:r>
-                    </a:p>
-                  </a:txBody>
-                  <a:tcPr marL="4649" marR="4649" marT="4649" marB="4649" anchor="ctr">
-                    <a:lnL>
-                      <a:noFill/>
-                    </a:lnL>
-                    <a:lnR>
-                      <a:noFill/>
-                    </a:lnR>
-                    <a:lnT>
-                      <a:noFill/>
-                    </a:lnT>
-                    <a:lnB>
-                      <a:noFill/>
-                    </a:lnB>
-                    <a:solidFill>
-                      <a:srgbClr val="FFFFFF"/>
-                    </a:solidFill>
-                  </a:tcPr>
-                </a:tc>
-                <a:extLst>
-                  <a:ext uri="{0D108BD9-81ED-4DB2-BD59-A6C34878D82A}">
-                    <a16:rowId xmlns:a16="http://schemas.microsoft.com/office/drawing/2014/main" val="2448716580"/>
-                  </a:ext>
-                </a:extLst>
-              </a:tr>
-              <a:tr h="280658">
-                <a:tc>
-                  <a:txBody>
-                    <a:bodyPr/>
-                    <a:lstStyle/>
-                    <a:p>
-                      <a:r>
-                        <a:rPr lang="en-US" sz="1800">
-                          <a:effectLst/>
-                        </a:rPr>
-                        <a:t>12</a:t>
-                      </a:r>
-                    </a:p>
-                  </a:txBody>
-                  <a:tcPr marL="4649" marR="4649" marT="4649" marB="4649" anchor="ctr">
-                    <a:lnL>
-                      <a:noFill/>
-                    </a:lnL>
-                    <a:lnR>
-                      <a:noFill/>
-                    </a:lnR>
-                    <a:lnT>
-                      <a:noFill/>
-                    </a:lnT>
-                    <a:lnB>
-                      <a:noFill/>
-                    </a:lnB>
-                    <a:solidFill>
-                      <a:srgbClr val="FFFFFF"/>
-                    </a:solidFill>
-                  </a:tcPr>
-                </a:tc>
-                <a:tc>
-                  <a:txBody>
-                    <a:bodyPr/>
-                    <a:lstStyle/>
-                    <a:p>
-                      <a:r>
-                        <a:rPr lang="en-US" sz="1800" dirty="0">
-                          <a:effectLst/>
-                        </a:rPr>
-                        <a:t>11/11/2024</a:t>
-                      </a:r>
-                    </a:p>
-                  </a:txBody>
-                  <a:tcPr marL="4649" marR="4649" marT="4649" marB="4649" anchor="ctr">
-                    <a:lnL>
-                      <a:noFill/>
-                    </a:lnL>
-                    <a:lnR>
-                      <a:noFill/>
-                    </a:lnR>
-                    <a:lnT>
-                      <a:noFill/>
-                    </a:lnT>
-                    <a:lnB>
-                      <a:noFill/>
-                    </a:lnB>
-                    <a:solidFill>
-                      <a:srgbClr val="FFFFFF"/>
-                    </a:solidFill>
-                  </a:tcPr>
-                </a:tc>
-                <a:tc>
-                  <a:txBody>
-                    <a:bodyPr/>
-                    <a:lstStyle/>
-                    <a:p>
-                      <a:r>
-                        <a:rPr lang="en-US" sz="1800" dirty="0">
-                          <a:effectLst/>
-                        </a:rPr>
-                        <a:t>OCR Text Detection</a:t>
-                      </a:r>
-                    </a:p>
-                  </a:txBody>
-                  <a:tcPr marL="4649" marR="4649" marT="4649" marB="4649" anchor="ctr">
-                    <a:lnL>
-                      <a:noFill/>
-                    </a:lnL>
-                    <a:lnR>
-                      <a:noFill/>
-                    </a:lnR>
-                    <a:lnT>
-                      <a:noFill/>
-                    </a:lnT>
-                    <a:lnB>
-                      <a:noFill/>
-                    </a:lnB>
-                    <a:solidFill>
-                      <a:srgbClr val="FFFFFF"/>
-                    </a:solidFill>
-                  </a:tcPr>
-                </a:tc>
-                <a:tc>
-                  <a:txBody>
-                    <a:bodyPr/>
-                    <a:lstStyle/>
-                    <a:p>
-                      <a:r>
-                        <a:rPr lang="en-US" sz="1800" dirty="0">
-                          <a:effectLst/>
-                        </a:rPr>
-                        <a:t>Group Project work</a:t>
-                      </a:r>
-                    </a:p>
-                  </a:txBody>
-                  <a:tcPr marL="4649" marR="4649" marT="4649" marB="4649" anchor="ctr">
-                    <a:lnL>
-                      <a:noFill/>
-                    </a:lnL>
-                    <a:lnR>
-                      <a:noFill/>
-                    </a:lnR>
-                    <a:lnT>
-                      <a:noFill/>
-                    </a:lnT>
-                    <a:lnB>
-                      <a:noFill/>
-                    </a:lnB>
-                    <a:solidFill>
-                      <a:srgbClr val="FFFFFF"/>
-                    </a:solidFill>
-                  </a:tcPr>
-                </a:tc>
-                <a:tc>
-                  <a:txBody>
-                    <a:bodyPr/>
-                    <a:lstStyle/>
-                    <a:p>
-                      <a:endParaRPr lang="en-US" sz="1800" dirty="0">
-                        <a:effectLst/>
-                      </a:endParaRPr>
-                    </a:p>
-                  </a:txBody>
-                  <a:tcPr marL="4649" marR="4649" marT="4649" marB="4649" anchor="ctr">
-                    <a:lnL>
-                      <a:noFill/>
-                    </a:lnL>
-                    <a:lnR>
-                      <a:noFill/>
-                    </a:lnR>
-                    <a:lnT>
-                      <a:noFill/>
-                    </a:lnT>
-                    <a:lnB>
-                      <a:noFill/>
-                    </a:lnB>
-                    <a:solidFill>
-                      <a:srgbClr val="FFFFFF"/>
-                    </a:solidFill>
-                  </a:tcPr>
-                </a:tc>
-                <a:extLst>
-                  <a:ext uri="{0D108BD9-81ED-4DB2-BD59-A6C34878D82A}">
-                    <a16:rowId xmlns:a16="http://schemas.microsoft.com/office/drawing/2014/main" val="2780081299"/>
-                  </a:ext>
-                </a:extLst>
-              </a:tr>
-              <a:tr h="191244">
-                <a:tc>
-                  <a:txBody>
-                    <a:bodyPr/>
-                    <a:lstStyle/>
-                    <a:p>
-                      <a:r>
-                        <a:rPr lang="en-US" sz="1800">
-                          <a:effectLst/>
-                        </a:rPr>
-                        <a:t> </a:t>
-                      </a:r>
-                    </a:p>
-                  </a:txBody>
-                  <a:tcPr marL="4649" marR="4649" marT="4649" marB="4649" anchor="ctr">
-                    <a:lnL>
-                      <a:noFill/>
-                    </a:lnL>
-                    <a:lnR>
-                      <a:noFill/>
-                    </a:lnR>
-                    <a:lnT>
-                      <a:noFill/>
-                    </a:lnT>
-                    <a:lnB>
-                      <a:noFill/>
-                    </a:lnB>
-                    <a:solidFill>
-                      <a:srgbClr val="FFFFFF"/>
-                    </a:solidFill>
-                  </a:tcPr>
-                </a:tc>
-                <a:tc>
-                  <a:txBody>
-                    <a:bodyPr/>
-                    <a:lstStyle/>
-                    <a:p>
-                      <a:r>
-                        <a:rPr lang="en-US" sz="1800">
-                          <a:effectLst/>
-                        </a:rPr>
-                        <a:t>11/13/2024</a:t>
-                      </a:r>
-                    </a:p>
-                  </a:txBody>
-                  <a:tcPr marL="4649" marR="4649" marT="4649" marB="4649" anchor="ctr">
-                    <a:lnL>
-                      <a:noFill/>
-                    </a:lnL>
-                    <a:lnR>
-                      <a:noFill/>
-                    </a:lnR>
-                    <a:lnT>
-                      <a:noFill/>
-                    </a:lnT>
-                    <a:lnB>
-                      <a:noFill/>
-                    </a:lnB>
-                    <a:solidFill>
-                      <a:srgbClr val="FFFFFF"/>
-                    </a:solidFill>
-                  </a:tcPr>
-                </a:tc>
-                <a:tc>
-                  <a:txBody>
-                    <a:bodyPr/>
-                    <a:lstStyle/>
-                    <a:p>
-                      <a:r>
-                        <a:rPr lang="en-US" sz="1800" dirty="0">
-                          <a:effectLst/>
-                        </a:rPr>
-                        <a:t>OpenCV DNN</a:t>
-                      </a:r>
-                    </a:p>
-                  </a:txBody>
-                  <a:tcPr marL="4649" marR="4649" marT="4649" marB="4649" anchor="ctr">
-                    <a:lnL>
-                      <a:noFill/>
-                    </a:lnL>
-                    <a:lnR>
-                      <a:noFill/>
-                    </a:lnR>
-                    <a:lnT>
-                      <a:noFill/>
-                    </a:lnT>
-                    <a:lnB>
-                      <a:noFill/>
-                    </a:lnB>
-                    <a:solidFill>
-                      <a:srgbClr val="FFFFFF"/>
-                    </a:solidFill>
-                  </a:tcPr>
-                </a:tc>
-                <a:tc>
-                  <a:txBody>
-                    <a:bodyPr/>
-                    <a:lstStyle/>
-                    <a:p>
-                      <a:r>
-                        <a:rPr lang="en-US" sz="1800" dirty="0">
-                          <a:effectLst/>
-                        </a:rPr>
-                        <a:t>Python problems (HW9)</a:t>
-                      </a:r>
-                    </a:p>
-                  </a:txBody>
-                  <a:tcPr marL="4649" marR="4649" marT="4649" marB="4649" anchor="ctr">
-                    <a:lnL>
-                      <a:noFill/>
-                    </a:lnL>
-                    <a:lnR>
-                      <a:noFill/>
-                    </a:lnR>
-                    <a:lnT>
-                      <a:noFill/>
-                    </a:lnT>
-                    <a:lnB>
-                      <a:noFill/>
-                    </a:lnB>
-                    <a:solidFill>
-                      <a:srgbClr val="FFFFFF"/>
-                    </a:solidFill>
-                  </a:tcPr>
-                </a:tc>
-                <a:tc>
-                  <a:txBody>
-                    <a:bodyPr/>
-                    <a:lstStyle/>
-                    <a:p>
-                      <a:r>
-                        <a:rPr lang="en-US" sz="1800" dirty="0">
-                          <a:effectLst/>
-                        </a:rPr>
-                        <a:t>Due 11/20</a:t>
-                      </a:r>
-                    </a:p>
-                  </a:txBody>
-                  <a:tcPr marL="4649" marR="4649" marT="4649" marB="4649" anchor="ctr">
-                    <a:lnL>
-                      <a:noFill/>
-                    </a:lnL>
-                    <a:lnR>
-                      <a:noFill/>
-                    </a:lnR>
-                    <a:lnT>
-                      <a:noFill/>
-                    </a:lnT>
-                    <a:lnB>
-                      <a:noFill/>
-                    </a:lnB>
-                    <a:solidFill>
-                      <a:srgbClr val="FFFFFF"/>
-                    </a:solidFill>
-                  </a:tcPr>
-                </a:tc>
-                <a:extLst>
-                  <a:ext uri="{0D108BD9-81ED-4DB2-BD59-A6C34878D82A}">
-                    <a16:rowId xmlns:a16="http://schemas.microsoft.com/office/drawing/2014/main" val="37833494"/>
-                  </a:ext>
-                </a:extLst>
-              </a:tr>
-              <a:tr h="191244">
-                <a:tc>
-                  <a:txBody>
-                    <a:bodyPr/>
-                    <a:lstStyle/>
-                    <a:p>
-                      <a:r>
-                        <a:rPr lang="en-US" sz="1800">
-                          <a:effectLst/>
-                        </a:rPr>
-                        <a:t>13</a:t>
-                      </a:r>
-                    </a:p>
-                  </a:txBody>
-                  <a:tcPr marL="4649" marR="4649" marT="4649" marB="4649" anchor="ctr">
-                    <a:lnL>
-                      <a:noFill/>
-                    </a:lnL>
-                    <a:lnR>
-                      <a:noFill/>
-                    </a:lnR>
-                    <a:lnT>
-                      <a:noFill/>
-                    </a:lnT>
-                    <a:lnB>
-                      <a:noFill/>
-                    </a:lnB>
-                    <a:solidFill>
-                      <a:srgbClr val="FFFFFF"/>
-                    </a:solidFill>
-                  </a:tcPr>
-                </a:tc>
-                <a:tc>
-                  <a:txBody>
-                    <a:bodyPr/>
-                    <a:lstStyle/>
-                    <a:p>
-                      <a:r>
-                        <a:rPr lang="en-US" sz="1800">
-                          <a:effectLst/>
-                        </a:rPr>
-                        <a:t>11/18/2024</a:t>
-                      </a:r>
-                    </a:p>
-                  </a:txBody>
-                  <a:tcPr marL="4649" marR="4649" marT="4649" marB="4649" anchor="ctr">
-                    <a:lnL>
-                      <a:noFill/>
-                    </a:lnL>
-                    <a:lnR>
-                      <a:noFill/>
-                    </a:lnR>
-                    <a:lnT>
-                      <a:noFill/>
-                    </a:lnT>
-                    <a:lnB>
-                      <a:noFill/>
-                    </a:lnB>
-                    <a:solidFill>
-                      <a:srgbClr val="FFFFFF"/>
-                    </a:solidFill>
-                  </a:tcPr>
-                </a:tc>
-                <a:tc>
-                  <a:txBody>
-                    <a:bodyPr/>
-                    <a:lstStyle/>
-                    <a:p>
-                      <a:r>
-                        <a:rPr lang="en-US" sz="1800" dirty="0">
-                          <a:effectLst/>
-                        </a:rPr>
-                        <a:t>Super Resolution</a:t>
                       </a:r>
                     </a:p>
                   </a:txBody>
@@ -23286,7 +22640,7 @@
                         <a:rPr lang="en-US" sz="1800" dirty="0">
                           <a:effectLst/>
                         </a:rPr>
-                        <a:t>Python problems (HW10)</a:t>
+                        <a:t>Object Tracking</a:t>
                       </a:r>
                     </a:p>
                   </a:txBody>
@@ -23313,12 +22667,60 @@
                     <a:bodyPr/>
                     <a:lstStyle/>
                     <a:p>
+                      <a:pPr marL="0" marR="0" lvl="0" indent="0" algn="l" defTabSz="914400" rtl="0" eaLnBrk="1" fontAlgn="auto" latinLnBrk="0" hangingPunct="1">
+                        <a:lnSpc>
+                          <a:spcPct val="100000"/>
+                        </a:lnSpc>
+                        <a:spcBef>
+                          <a:spcPts val="0"/>
+                        </a:spcBef>
+                        <a:spcAft>
+                          <a:spcPts val="0"/>
+                        </a:spcAft>
+                        <a:buClrTx/>
+                        <a:buSzTx/>
+                        <a:buFontTx/>
+                        <a:buNone/>
+                        <a:tabLst/>
+                        <a:defRPr/>
+                      </a:pPr>
                       <a:r>
                         <a:rPr lang="en-US" sz="1800" dirty="0">
                           <a:effectLst/>
+                          <a:highlight>
+                            <a:srgbClr val="FFFF00"/>
+                          </a:highlight>
                         </a:rPr>
-                        <a:t>Due 12/4</a:t>
+                        <a:t>Project updates</a:t>
                       </a:r>
+                    </a:p>
+                  </a:txBody>
+                  <a:tcPr marL="4649" marR="4649" marT="4649" marB="4649" anchor="ctr">
+                    <a:lnL>
+                      <a:noFill/>
+                    </a:lnL>
+                    <a:lnR>
+                      <a:noFill/>
+                    </a:lnR>
+                    <a:lnT>
+                      <a:noFill/>
+                    </a:lnT>
+                    <a:lnB>
+                      <a:noFill/>
+                    </a:lnB>
+                    <a:solidFill>
+                      <a:srgbClr val="FFFFFF"/>
+                    </a:solidFill>
+                  </a:tcPr>
+                </a:tc>
+                <a:tc>
+                  <a:txBody>
+                    <a:bodyPr/>
+                    <a:lstStyle/>
+                    <a:p>
+                      <a:endParaRPr lang="en-US" sz="1800" dirty="0">
+                        <a:effectLst/>
+                      </a:endParaRPr>
                     </a:p>
                   </a:txBody>
                   <a:tcPr marL="4649" marR="4649" marT="4649" marB="4649" anchor="ctr">
@@ -23341,7 +22743,7 @@
                 </a:tc>
                 <a:extLst>
                   <a:ext uri="{0D108BD9-81ED-4DB2-BD59-A6C34878D82A}">
-                    <a16:rowId xmlns:a16="http://schemas.microsoft.com/office/drawing/2014/main" val="320480187"/>
+                    <a16:rowId xmlns:a16="http://schemas.microsoft.com/office/drawing/2014/main" val="3111691061"/>
                   </a:ext>
                 </a:extLst>
               </a:tr>
@@ -23386,7 +22788,186 @@
                         <a:rPr lang="en-US" sz="1800">
                           <a:effectLst/>
                         </a:rPr>
-                        <a:t>11/20/2024</a:t>
+                        <a:t>11/6/2024</a:t>
+                      </a:r>
+                    </a:p>
+                  </a:txBody>
+                  <a:tcPr marL="4649" marR="4649" marT="4649" marB="4649" anchor="ctr">
+                    <a:lnL>
+                      <a:noFill/>
+                    </a:lnL>
+                    <a:lnR>
+                      <a:noFill/>
+                    </a:lnR>
+                    <a:lnT>
+                      <a:noFill/>
+                    </a:lnT>
+                    <a:lnB>
+                      <a:noFill/>
+                    </a:lnB>
+                    <a:solidFill>
+                      <a:srgbClr val="FFFFFF"/>
+                    </a:solidFill>
+                  </a:tcPr>
+                </a:tc>
+                <a:tc>
+                  <a:txBody>
+                    <a:bodyPr/>
+                    <a:lstStyle/>
+                    <a:p>
+                      <a:pPr marL="0" marR="0" lvl="0" indent="0" algn="l" defTabSz="914400" rtl="0" eaLnBrk="1" fontAlgn="auto" latinLnBrk="0" hangingPunct="1">
+                        <a:lnSpc>
+                          <a:spcPct val="100000"/>
+                        </a:lnSpc>
+                        <a:spcBef>
+                          <a:spcPts val="0"/>
+                        </a:spcBef>
+                        <a:spcAft>
+                          <a:spcPts val="0"/>
+                        </a:spcAft>
+                        <a:buClrTx/>
+                        <a:buSzTx/>
+                        <a:buFontTx/>
+                        <a:buNone/>
+                        <a:tabLst/>
+                        <a:defRPr/>
+                      </a:pPr>
+                      <a:r>
+                        <a:rPr lang="en-US" sz="1800" dirty="0">
+                          <a:effectLst/>
+                        </a:rPr>
+                        <a:t>OCR Text Detection</a:t>
+                      </a:r>
+                    </a:p>
+                  </a:txBody>
+                  <a:tcPr marL="4649" marR="4649" marT="4649" marB="4649" anchor="ctr">
+                    <a:lnL>
+                      <a:noFill/>
+                    </a:lnL>
+                    <a:lnR>
+                      <a:noFill/>
+                    </a:lnR>
+                    <a:lnT>
+                      <a:noFill/>
+                    </a:lnT>
+                    <a:lnB>
+                      <a:noFill/>
+                    </a:lnB>
+                    <a:solidFill>
+                      <a:srgbClr val="FFFFFF"/>
+                    </a:solidFill>
+                  </a:tcPr>
+                </a:tc>
+                <a:tc>
+                  <a:txBody>
+                    <a:bodyPr/>
+                    <a:lstStyle/>
+                    <a:p>
+                      <a:r>
+                        <a:rPr lang="en-US" sz="1800" dirty="0">
+                          <a:effectLst/>
+                        </a:rPr>
+                        <a:t>Python problems (HW8)</a:t>
+                      </a:r>
+                    </a:p>
+                  </a:txBody>
+                  <a:tcPr marL="4649" marR="4649" marT="4649" marB="4649" anchor="ctr">
+                    <a:lnL>
+                      <a:noFill/>
+                    </a:lnL>
+                    <a:lnR>
+                      <a:noFill/>
+                    </a:lnR>
+                    <a:lnT>
+                      <a:noFill/>
+                    </a:lnT>
+                    <a:lnB>
+                      <a:noFill/>
+                    </a:lnB>
+                    <a:solidFill>
+                      <a:srgbClr val="FFFFFF"/>
+                    </a:solidFill>
+                  </a:tcPr>
+                </a:tc>
+                <a:tc>
+                  <a:txBody>
+                    <a:bodyPr/>
+                    <a:lstStyle/>
+                    <a:p>
+                      <a:r>
+                        <a:rPr lang="en-US" sz="1800" dirty="0">
+                          <a:effectLst/>
+                        </a:rPr>
+                        <a:t>Due 11/13</a:t>
+                      </a:r>
+                    </a:p>
+                  </a:txBody>
+                  <a:tcPr marL="4649" marR="4649" marT="4649" marB="4649" anchor="ctr">
+                    <a:lnL>
+                      <a:noFill/>
+                    </a:lnL>
+                    <a:lnR>
+                      <a:noFill/>
+                    </a:lnR>
+                    <a:lnT>
+                      <a:noFill/>
+                    </a:lnT>
+                    <a:lnB>
+                      <a:noFill/>
+                    </a:lnB>
+                    <a:solidFill>
+                      <a:srgbClr val="FFFFFF"/>
+                    </a:solidFill>
+                  </a:tcPr>
+                </a:tc>
+                <a:extLst>
+                  <a:ext uri="{0D108BD9-81ED-4DB2-BD59-A6C34878D82A}">
+                    <a16:rowId xmlns:a16="http://schemas.microsoft.com/office/drawing/2014/main" val="2448716580"/>
+                  </a:ext>
+                </a:extLst>
+              </a:tr>
+              <a:tr h="280658">
+                <a:tc>
+                  <a:txBody>
+                    <a:bodyPr/>
+                    <a:lstStyle/>
+                    <a:p>
+                      <a:r>
+                        <a:rPr lang="en-US" sz="1800">
+                          <a:effectLst/>
+                        </a:rPr>
+                        <a:t>12</a:t>
+                      </a:r>
+                    </a:p>
+                  </a:txBody>
+                  <a:tcPr marL="4649" marR="4649" marT="4649" marB="4649" anchor="ctr">
+                    <a:lnL>
+                      <a:noFill/>
+                    </a:lnL>
+                    <a:lnR>
+                      <a:noFill/>
+                    </a:lnR>
+                    <a:lnT>
+                      <a:noFill/>
+                    </a:lnT>
+                    <a:lnB>
+                      <a:noFill/>
+                    </a:lnB>
+                    <a:solidFill>
+                      <a:srgbClr val="FFFFFF"/>
+                    </a:solidFill>
+                  </a:tcPr>
+                </a:tc>
+                <a:tc>
+                  <a:txBody>
+                    <a:bodyPr/>
+                    <a:lstStyle/>
+                    <a:p>
+                      <a:r>
+                        <a:rPr lang="en-US" sz="1800" dirty="0">
+                          <a:effectLst/>
+                        </a:rPr>
+                        <a:t>11/11/2024</a:t>
                       </a:r>
                     </a:p>
                   </a:txBody>
@@ -23441,6 +23022,540 @@
                           <a:effectLst/>
                         </a:rPr>
                         <a:t>/SLAM</a:t>
+                      </a:r>
+                    </a:p>
+                  </a:txBody>
+                  <a:tcPr marL="4649" marR="4649" marT="4649" marB="4649" anchor="ctr">
+                    <a:lnL>
+                      <a:noFill/>
+                    </a:lnL>
+                    <a:lnR>
+                      <a:noFill/>
+                    </a:lnR>
+                    <a:lnT>
+                      <a:noFill/>
+                    </a:lnT>
+                    <a:lnB>
+                      <a:noFill/>
+                    </a:lnB>
+                    <a:solidFill>
+                      <a:srgbClr val="FFFFFF"/>
+                    </a:solidFill>
+                  </a:tcPr>
+                </a:tc>
+                <a:tc>
+                  <a:txBody>
+                    <a:bodyPr/>
+                    <a:lstStyle/>
+                    <a:p>
+                      <a:r>
+                        <a:rPr lang="en-US" sz="1800" dirty="0">
+                          <a:effectLst/>
+                        </a:rPr>
+                        <a:t>Group Project work</a:t>
+                      </a:r>
+                    </a:p>
+                  </a:txBody>
+                  <a:tcPr marL="4649" marR="4649" marT="4649" marB="4649" anchor="ctr">
+                    <a:lnL>
+                      <a:noFill/>
+                    </a:lnL>
+                    <a:lnR>
+                      <a:noFill/>
+                    </a:lnR>
+                    <a:lnT>
+                      <a:noFill/>
+                    </a:lnT>
+                    <a:lnB>
+                      <a:noFill/>
+                    </a:lnB>
+                    <a:solidFill>
+                      <a:srgbClr val="FFFFFF"/>
+                    </a:solidFill>
+                  </a:tcPr>
+                </a:tc>
+                <a:tc>
+                  <a:txBody>
+                    <a:bodyPr/>
+                    <a:lstStyle/>
+                    <a:p>
+                      <a:endParaRPr lang="en-US" sz="1800" dirty="0">
+                        <a:effectLst/>
+                      </a:endParaRPr>
+                    </a:p>
+                  </a:txBody>
+                  <a:tcPr marL="4649" marR="4649" marT="4649" marB="4649" anchor="ctr">
+                    <a:lnL>
+                      <a:noFill/>
+                    </a:lnL>
+                    <a:lnR>
+                      <a:noFill/>
+                    </a:lnR>
+                    <a:lnT>
+                      <a:noFill/>
+                    </a:lnT>
+                    <a:lnB>
+                      <a:noFill/>
+                    </a:lnB>
+                    <a:solidFill>
+                      <a:srgbClr val="FFFFFF"/>
+                    </a:solidFill>
+                  </a:tcPr>
+                </a:tc>
+                <a:extLst>
+                  <a:ext uri="{0D108BD9-81ED-4DB2-BD59-A6C34878D82A}">
+                    <a16:rowId xmlns:a16="http://schemas.microsoft.com/office/drawing/2014/main" val="2780081299"/>
+                  </a:ext>
+                </a:extLst>
+              </a:tr>
+              <a:tr h="191244">
+                <a:tc>
+                  <a:txBody>
+                    <a:bodyPr/>
+                    <a:lstStyle/>
+                    <a:p>
+                      <a:r>
+                        <a:rPr lang="en-US" sz="1800">
+                          <a:effectLst/>
+                        </a:rPr>
+                        <a:t> </a:t>
+                      </a:r>
+                    </a:p>
+                  </a:txBody>
+                  <a:tcPr marL="4649" marR="4649" marT="4649" marB="4649" anchor="ctr">
+                    <a:lnL>
+                      <a:noFill/>
+                    </a:lnL>
+                    <a:lnR>
+                      <a:noFill/>
+                    </a:lnR>
+                    <a:lnT>
+                      <a:noFill/>
+                    </a:lnT>
+                    <a:lnB>
+                      <a:noFill/>
+                    </a:lnB>
+                    <a:solidFill>
+                      <a:srgbClr val="FFFFFF"/>
+                    </a:solidFill>
+                  </a:tcPr>
+                </a:tc>
+                <a:tc>
+                  <a:txBody>
+                    <a:bodyPr/>
+                    <a:lstStyle/>
+                    <a:p>
+                      <a:r>
+                        <a:rPr lang="en-US" sz="1800">
+                          <a:effectLst/>
+                        </a:rPr>
+                        <a:t>11/13/2024</a:t>
+                      </a:r>
+                    </a:p>
+                  </a:txBody>
+                  <a:tcPr marL="4649" marR="4649" marT="4649" marB="4649" anchor="ctr">
+                    <a:lnL>
+                      <a:noFill/>
+                    </a:lnL>
+                    <a:lnR>
+                      <a:noFill/>
+                    </a:lnR>
+                    <a:lnT>
+                      <a:noFill/>
+                    </a:lnT>
+                    <a:lnB>
+                      <a:noFill/>
+                    </a:lnB>
+                    <a:solidFill>
+                      <a:srgbClr val="FFFFFF"/>
+                    </a:solidFill>
+                  </a:tcPr>
+                </a:tc>
+                <a:tc>
+                  <a:txBody>
+                    <a:bodyPr/>
+                    <a:lstStyle/>
+                    <a:p>
+                      <a:r>
+                        <a:rPr lang="en-US" sz="1800" dirty="0">
+                          <a:effectLst/>
+                        </a:rPr>
+                        <a:t>OpenCV DNN</a:t>
+                      </a:r>
+                    </a:p>
+                  </a:txBody>
+                  <a:tcPr marL="4649" marR="4649" marT="4649" marB="4649" anchor="ctr">
+                    <a:lnL>
+                      <a:noFill/>
+                    </a:lnL>
+                    <a:lnR>
+                      <a:noFill/>
+                    </a:lnR>
+                    <a:lnT>
+                      <a:noFill/>
+                    </a:lnT>
+                    <a:lnB>
+                      <a:noFill/>
+                    </a:lnB>
+                    <a:solidFill>
+                      <a:srgbClr val="FFFFFF"/>
+                    </a:solidFill>
+                  </a:tcPr>
+                </a:tc>
+                <a:tc>
+                  <a:txBody>
+                    <a:bodyPr/>
+                    <a:lstStyle/>
+                    <a:p>
+                      <a:r>
+                        <a:rPr lang="en-US" sz="1800" dirty="0">
+                          <a:effectLst/>
+                        </a:rPr>
+                        <a:t>Python problems (HW9)</a:t>
+                      </a:r>
+                    </a:p>
+                  </a:txBody>
+                  <a:tcPr marL="4649" marR="4649" marT="4649" marB="4649" anchor="ctr">
+                    <a:lnL>
+                      <a:noFill/>
+                    </a:lnL>
+                    <a:lnR>
+                      <a:noFill/>
+                    </a:lnR>
+                    <a:lnT>
+                      <a:noFill/>
+                    </a:lnT>
+                    <a:lnB>
+                      <a:noFill/>
+                    </a:lnB>
+                    <a:solidFill>
+                      <a:srgbClr val="FFFFFF"/>
+                    </a:solidFill>
+                  </a:tcPr>
+                </a:tc>
+                <a:tc>
+                  <a:txBody>
+                    <a:bodyPr/>
+                    <a:lstStyle/>
+                    <a:p>
+                      <a:r>
+                        <a:rPr lang="en-US" sz="1800" dirty="0">
+                          <a:effectLst/>
+                        </a:rPr>
+                        <a:t>Due 11/20</a:t>
+                      </a:r>
+                    </a:p>
+                  </a:txBody>
+                  <a:tcPr marL="4649" marR="4649" marT="4649" marB="4649" anchor="ctr">
+                    <a:lnL>
+                      <a:noFill/>
+                    </a:lnL>
+                    <a:lnR>
+                      <a:noFill/>
+                    </a:lnR>
+                    <a:lnT>
+                      <a:noFill/>
+                    </a:lnT>
+                    <a:lnB>
+                      <a:noFill/>
+                    </a:lnB>
+                    <a:solidFill>
+                      <a:srgbClr val="FFFFFF"/>
+                    </a:solidFill>
+                  </a:tcPr>
+                </a:tc>
+                <a:extLst>
+                  <a:ext uri="{0D108BD9-81ED-4DB2-BD59-A6C34878D82A}">
+                    <a16:rowId xmlns:a16="http://schemas.microsoft.com/office/drawing/2014/main" val="37833494"/>
+                  </a:ext>
+                </a:extLst>
+              </a:tr>
+              <a:tr h="191244">
+                <a:tc>
+                  <a:txBody>
+                    <a:bodyPr/>
+                    <a:lstStyle/>
+                    <a:p>
+                      <a:r>
+                        <a:rPr lang="en-US" sz="1800">
+                          <a:effectLst/>
+                        </a:rPr>
+                        <a:t>13</a:t>
+                      </a:r>
+                    </a:p>
+                  </a:txBody>
+                  <a:tcPr marL="4649" marR="4649" marT="4649" marB="4649" anchor="ctr">
+                    <a:lnL>
+                      <a:noFill/>
+                    </a:lnL>
+                    <a:lnR>
+                      <a:noFill/>
+                    </a:lnR>
+                    <a:lnT>
+                      <a:noFill/>
+                    </a:lnT>
+                    <a:lnB>
+                      <a:noFill/>
+                    </a:lnB>
+                    <a:solidFill>
+                      <a:srgbClr val="FFFFFF"/>
+                    </a:solidFill>
+                  </a:tcPr>
+                </a:tc>
+                <a:tc>
+                  <a:txBody>
+                    <a:bodyPr/>
+                    <a:lstStyle/>
+                    <a:p>
+                      <a:r>
+                        <a:rPr lang="en-US" sz="1800">
+                          <a:effectLst/>
+                        </a:rPr>
+                        <a:t>11/18/2024</a:t>
+                      </a:r>
+                    </a:p>
+                  </a:txBody>
+                  <a:tcPr marL="4649" marR="4649" marT="4649" marB="4649" anchor="ctr">
+                    <a:lnL>
+                      <a:noFill/>
+                    </a:lnL>
+                    <a:lnR>
+                      <a:noFill/>
+                    </a:lnR>
+                    <a:lnT>
+                      <a:noFill/>
+                    </a:lnT>
+                    <a:lnB>
+                      <a:noFill/>
+                    </a:lnB>
+                    <a:solidFill>
+                      <a:srgbClr val="FFFFFF"/>
+                    </a:solidFill>
+                  </a:tcPr>
+                </a:tc>
+                <a:tc>
+                  <a:txBody>
+                    <a:bodyPr/>
+                    <a:lstStyle/>
+                    <a:p>
+                      <a:pPr marL="0" marR="0" lvl="0" indent="0" algn="l" defTabSz="914400" rtl="0" eaLnBrk="1" fontAlgn="auto" latinLnBrk="0" hangingPunct="1">
+                        <a:lnSpc>
+                          <a:spcPct val="100000"/>
+                        </a:lnSpc>
+                        <a:spcBef>
+                          <a:spcPts val="0"/>
+                        </a:spcBef>
+                        <a:spcAft>
+                          <a:spcPts val="0"/>
+                        </a:spcAft>
+                        <a:buClrTx/>
+                        <a:buSzTx/>
+                        <a:buFontTx/>
+                        <a:buNone/>
+                        <a:tabLst/>
+                        <a:defRPr/>
+                      </a:pPr>
+                      <a:r>
+                        <a:rPr lang="en-US" sz="1800" dirty="0">
+                          <a:effectLst/>
+                        </a:rPr>
+                        <a:t>Super Resolution</a:t>
+                      </a:r>
+                    </a:p>
+                  </a:txBody>
+                  <a:tcPr marL="4649" marR="4649" marT="4649" marB="4649" anchor="ctr">
+                    <a:lnL>
+                      <a:noFill/>
+                    </a:lnL>
+                    <a:lnR>
+                      <a:noFill/>
+                    </a:lnR>
+                    <a:lnT>
+                      <a:noFill/>
+                    </a:lnT>
+                    <a:lnB>
+                      <a:noFill/>
+                    </a:lnB>
+                    <a:solidFill>
+                      <a:srgbClr val="FFFFFF"/>
+                    </a:solidFill>
+                  </a:tcPr>
+                </a:tc>
+                <a:tc>
+                  <a:txBody>
+                    <a:bodyPr/>
+                    <a:lstStyle/>
+                    <a:p>
+                      <a:pPr marL="0" marR="0" lvl="0" indent="0" algn="l" defTabSz="914400" rtl="0" eaLnBrk="1" fontAlgn="auto" latinLnBrk="0" hangingPunct="1">
+                        <a:lnSpc>
+                          <a:spcPct val="100000"/>
+                        </a:lnSpc>
+                        <a:spcBef>
+                          <a:spcPts val="0"/>
+                        </a:spcBef>
+                        <a:spcAft>
+                          <a:spcPts val="0"/>
+                        </a:spcAft>
+                        <a:buClrTx/>
+                        <a:buSzTx/>
+                        <a:buFontTx/>
+                        <a:buNone/>
+                        <a:tabLst/>
+                        <a:defRPr/>
+                      </a:pPr>
+                      <a:r>
+                        <a:rPr lang="en-US" sz="1800" dirty="0">
+                          <a:effectLst/>
+                        </a:rPr>
+                        <a:t>Python problems (HW10)</a:t>
+                      </a:r>
+                    </a:p>
+                  </a:txBody>
+                  <a:tcPr marL="4649" marR="4649" marT="4649" marB="4649" anchor="ctr">
+                    <a:lnL>
+                      <a:noFill/>
+                    </a:lnL>
+                    <a:lnR>
+                      <a:noFill/>
+                    </a:lnR>
+                    <a:lnT>
+                      <a:noFill/>
+                    </a:lnT>
+                    <a:lnB>
+                      <a:noFill/>
+                    </a:lnB>
+                    <a:solidFill>
+                      <a:srgbClr val="FFFFFF"/>
+                    </a:solidFill>
+                  </a:tcPr>
+                </a:tc>
+                <a:tc>
+                  <a:txBody>
+                    <a:bodyPr/>
+                    <a:lstStyle/>
+                    <a:p>
+                      <a:r>
+                        <a:rPr lang="en-US" sz="1800" dirty="0">
+                          <a:effectLst/>
+                        </a:rPr>
+                        <a:t>Due 12/4</a:t>
+                      </a:r>
+                    </a:p>
+                  </a:txBody>
+                  <a:tcPr marL="4649" marR="4649" marT="4649" marB="4649" anchor="ctr">
+                    <a:lnL>
+                      <a:noFill/>
+                    </a:lnL>
+                    <a:lnR>
+                      <a:noFill/>
+                    </a:lnR>
+                    <a:lnT>
+                      <a:noFill/>
+                    </a:lnT>
+                    <a:lnB>
+                      <a:noFill/>
+                    </a:lnB>
+                    <a:solidFill>
+                      <a:srgbClr val="FFFFFF"/>
+                    </a:solidFill>
+                  </a:tcPr>
+                </a:tc>
+                <a:extLst>
+                  <a:ext uri="{0D108BD9-81ED-4DB2-BD59-A6C34878D82A}">
+                    <a16:rowId xmlns:a16="http://schemas.microsoft.com/office/drawing/2014/main" val="320480187"/>
+                  </a:ext>
+                </a:extLst>
+              </a:tr>
+              <a:tr h="191244">
+                <a:tc>
+                  <a:txBody>
+                    <a:bodyPr/>
+                    <a:lstStyle/>
+                    <a:p>
+                      <a:r>
+                        <a:rPr lang="en-US" sz="1800">
+                          <a:effectLst/>
+                        </a:rPr>
+                        <a:t> </a:t>
+                      </a:r>
+                    </a:p>
+                  </a:txBody>
+                  <a:tcPr marL="4649" marR="4649" marT="4649" marB="4649" anchor="ctr">
+                    <a:lnL>
+                      <a:noFill/>
+                    </a:lnL>
+                    <a:lnR>
+                      <a:noFill/>
+                    </a:lnR>
+                    <a:lnT>
+                      <a:noFill/>
+                    </a:lnT>
+                    <a:lnB>
+                      <a:noFill/>
+                    </a:lnB>
+                    <a:solidFill>
+                      <a:srgbClr val="FFFFFF"/>
+                    </a:solidFill>
+                  </a:tcPr>
+                </a:tc>
+                <a:tc>
+                  <a:txBody>
+                    <a:bodyPr/>
+                    <a:lstStyle/>
+                    <a:p>
+                      <a:r>
+                        <a:rPr lang="en-US" sz="1800">
+                          <a:effectLst/>
+                        </a:rPr>
+                        <a:t>11/20/2024</a:t>
+                      </a:r>
+                    </a:p>
+                  </a:txBody>
+                  <a:tcPr marL="4649" marR="4649" marT="4649" marB="4649" anchor="ctr">
+                    <a:lnL>
+                      <a:noFill/>
+                    </a:lnL>
+                    <a:lnR>
+                      <a:noFill/>
+                    </a:lnR>
+                    <a:lnT>
+                      <a:noFill/>
+                    </a:lnT>
+                    <a:lnB>
+                      <a:noFill/>
+                    </a:lnB>
+                    <a:solidFill>
+                      <a:srgbClr val="FFFFFF"/>
+                    </a:solidFill>
+                  </a:tcPr>
+                </a:tc>
+                <a:tc>
+                  <a:txBody>
+                    <a:bodyPr/>
+                    <a:lstStyle/>
+                    <a:p>
+                      <a:pPr marL="0" marR="0" lvl="0" indent="0" algn="l" defTabSz="914400" rtl="0" eaLnBrk="1" fontAlgn="auto" latinLnBrk="0" hangingPunct="1">
+                        <a:lnSpc>
+                          <a:spcPct val="100000"/>
+                        </a:lnSpc>
+                        <a:spcBef>
+                          <a:spcPts val="0"/>
+                        </a:spcBef>
+                        <a:spcAft>
+                          <a:spcPts val="0"/>
+                        </a:spcAft>
+                        <a:buClrTx/>
+                        <a:buSzTx/>
+                        <a:buFontTx/>
+                        <a:buNone/>
+                        <a:tabLst/>
+                        <a:defRPr/>
+                      </a:pPr>
+                      <a:r>
+                        <a:rPr lang="en-US" sz="1800" dirty="0">
+                          <a:effectLst/>
+                        </a:rPr>
+                        <a:t>Image compression</a:t>
                       </a:r>
                     </a:p>
                   </a:txBody>
@@ -24614,8 +24729,8 @@
           </a:extLst>
         </p:spPr>
       </p:pic>
-      <mc:AlternateContent xmlns:mc="http://schemas.openxmlformats.org/markup-compatibility/2006">
-        <mc:Choice xmlns:a14="http://schemas.microsoft.com/office/drawing/2010/main" Requires="a14">
+      <mc:AlternateContent xmlns:mc="http://schemas.openxmlformats.org/markup-compatibility/2006" xmlns:a14="http://schemas.microsoft.com/office/drawing/2010/main">
+        <mc:Choice Requires="a14">
           <p:sp>
             <p:nvSpPr>
               <p:cNvPr id="6" name="TextBox 5">
@@ -24644,6 +24759,7 @@
               </a:bodyPr>
               <a:lstStyle/>
               <a:p>
+                <a:pPr/>
                 <a14:m>
                   <m:oMathPara xmlns:m="http://schemas.openxmlformats.org/officeDocument/2006/math">
                     <m:oMathParaPr>
@@ -24816,7 +24932,7 @@
             </p:txBody>
           </p:sp>
         </mc:Choice>
-        <mc:Fallback>
+        <mc:Fallback xmlns="">
           <p:sp>
             <p:nvSpPr>
               <p:cNvPr id="6" name="TextBox 5">
@@ -24861,8 +24977,8 @@
           </p:sp>
         </mc:Fallback>
       </mc:AlternateContent>
-      <mc:AlternateContent xmlns:mc="http://schemas.openxmlformats.org/markup-compatibility/2006">
-        <mc:Choice xmlns:a14="http://schemas.microsoft.com/office/drawing/2010/main" Requires="a14">
+      <mc:AlternateContent xmlns:mc="http://schemas.openxmlformats.org/markup-compatibility/2006" xmlns:a14="http://schemas.microsoft.com/office/drawing/2010/main">
+        <mc:Choice Requires="a14">
           <p:sp>
             <p:nvSpPr>
               <p:cNvPr id="7" name="TextBox 6">
@@ -24891,6 +25007,7 @@
               </a:bodyPr>
               <a:lstStyle/>
               <a:p>
+                <a:pPr/>
                 <a14:m>
                   <m:oMathPara xmlns:m="http://schemas.openxmlformats.org/officeDocument/2006/math">
                     <m:oMathParaPr>
@@ -25102,7 +25219,7 @@
             </p:txBody>
           </p:sp>
         </mc:Choice>
-        <mc:Fallback>
+        <mc:Fallback xmlns="">
           <p:sp>
             <p:nvSpPr>
               <p:cNvPr id="7" name="TextBox 6">
@@ -25815,8 +25932,8 @@
           </a:p>
         </p:txBody>
       </p:sp>
-      <mc:AlternateContent xmlns:mc="http://schemas.openxmlformats.org/markup-compatibility/2006">
-        <mc:Choice xmlns:a14="http://schemas.microsoft.com/office/drawing/2010/main" Requires="a14">
+      <mc:AlternateContent xmlns:mc="http://schemas.openxmlformats.org/markup-compatibility/2006" xmlns:a14="http://schemas.microsoft.com/office/drawing/2010/main">
+        <mc:Choice Requires="a14">
           <p:sp>
             <p:nvSpPr>
               <p:cNvPr id="13" name="TextBox 12">
@@ -25845,6 +25962,7 @@
               </a:bodyPr>
               <a:lstStyle/>
               <a:p>
+                <a:pPr/>
                 <a14:m>
                   <m:oMathPara xmlns:m="http://schemas.openxmlformats.org/officeDocument/2006/math">
                     <m:oMathParaPr>
@@ -26064,7 +26182,7 @@
             </p:txBody>
           </p:sp>
         </mc:Choice>
-        <mc:Fallback>
+        <mc:Fallback xmlns="">
           <p:sp>
             <p:nvSpPr>
               <p:cNvPr id="13" name="TextBox 12">
@@ -26109,8 +26227,8 @@
           </p:sp>
         </mc:Fallback>
       </mc:AlternateContent>
-      <mc:AlternateContent xmlns:mc="http://schemas.openxmlformats.org/markup-compatibility/2006">
-        <mc:Choice xmlns:a14="http://schemas.microsoft.com/office/drawing/2010/main" Requires="a14">
+      <mc:AlternateContent xmlns:mc="http://schemas.openxmlformats.org/markup-compatibility/2006" xmlns:a14="http://schemas.microsoft.com/office/drawing/2010/main">
+        <mc:Choice Requires="a14">
           <p:sp>
             <p:nvSpPr>
               <p:cNvPr id="14" name="TextBox 13">
@@ -26139,6 +26257,7 @@
               </a:bodyPr>
               <a:lstStyle/>
               <a:p>
+                <a:pPr/>
                 <a14:m>
                   <m:oMathPara xmlns:m="http://schemas.openxmlformats.org/officeDocument/2006/math">
                     <m:oMathParaPr>
@@ -26585,7 +26704,7 @@
             </p:txBody>
           </p:sp>
         </mc:Choice>
-        <mc:Fallback>
+        <mc:Fallback xmlns="">
           <p:sp>
             <p:nvSpPr>
               <p:cNvPr id="14" name="TextBox 13">
@@ -26630,8 +26749,8 @@
           </p:sp>
         </mc:Fallback>
       </mc:AlternateContent>
-      <mc:AlternateContent xmlns:mc="http://schemas.openxmlformats.org/markup-compatibility/2006">
-        <mc:Choice xmlns:a14="http://schemas.microsoft.com/office/drawing/2010/main" Requires="a14">
+      <mc:AlternateContent xmlns:mc="http://schemas.openxmlformats.org/markup-compatibility/2006" xmlns:a14="http://schemas.microsoft.com/office/drawing/2010/main">
+        <mc:Choice Requires="a14">
           <p:sp>
             <p:nvSpPr>
               <p:cNvPr id="16" name="TextBox 15">
@@ -26759,7 +26878,7 @@
             </p:txBody>
           </p:sp>
         </mc:Choice>
-        <mc:Fallback>
+        <mc:Fallback xmlns="">
           <p:sp>
             <p:nvSpPr>
               <p:cNvPr id="16" name="TextBox 15">
@@ -26804,8 +26923,8 @@
           </p:sp>
         </mc:Fallback>
       </mc:AlternateContent>
-      <mc:AlternateContent xmlns:mc="http://schemas.openxmlformats.org/markup-compatibility/2006">
-        <mc:Choice xmlns:a14="http://schemas.microsoft.com/office/drawing/2010/main" Requires="a14">
+      <mc:AlternateContent xmlns:mc="http://schemas.openxmlformats.org/markup-compatibility/2006" xmlns:a14="http://schemas.microsoft.com/office/drawing/2010/main">
+        <mc:Choice Requires="a14">
           <p:sp>
             <p:nvSpPr>
               <p:cNvPr id="17" name="TextBox 16">
@@ -27020,7 +27139,7 @@
             </p:txBody>
           </p:sp>
         </mc:Choice>
-        <mc:Fallback>
+        <mc:Fallback xmlns="">
           <p:sp>
             <p:nvSpPr>
               <p:cNvPr id="17" name="TextBox 16">
@@ -27065,8 +27184,8 @@
           </p:sp>
         </mc:Fallback>
       </mc:AlternateContent>
-      <mc:AlternateContent xmlns:mc="http://schemas.openxmlformats.org/markup-compatibility/2006">
-        <mc:Choice xmlns:a14="http://schemas.microsoft.com/office/drawing/2010/main" Requires="a14">
+      <mc:AlternateContent xmlns:mc="http://schemas.openxmlformats.org/markup-compatibility/2006" xmlns:a14="http://schemas.microsoft.com/office/drawing/2010/main">
+        <mc:Choice Requires="a14">
           <p:sp>
             <p:nvSpPr>
               <p:cNvPr id="18" name="TextBox 17">
@@ -27311,7 +27430,7 @@
             </p:txBody>
           </p:sp>
         </mc:Choice>
-        <mc:Fallback>
+        <mc:Fallback xmlns="">
           <p:sp>
             <p:nvSpPr>
               <p:cNvPr id="18" name="TextBox 17">
@@ -27399,8 +27518,8 @@
           </a:p>
         </p:txBody>
       </p:sp>
-      <mc:AlternateContent xmlns:mc="http://schemas.openxmlformats.org/markup-compatibility/2006">
-        <mc:Choice xmlns:a14="http://schemas.microsoft.com/office/drawing/2010/main" Requires="a14">
+      <mc:AlternateContent xmlns:mc="http://schemas.openxmlformats.org/markup-compatibility/2006" xmlns:a14="http://schemas.microsoft.com/office/drawing/2010/main">
+        <mc:Choice Requires="a14">
           <p:sp>
             <p:nvSpPr>
               <p:cNvPr id="20" name="TextBox 19">
@@ -27429,6 +27548,7 @@
               </a:bodyPr>
               <a:lstStyle/>
               <a:p>
+                <a:pPr/>
                 <a14:m>
                   <m:oMathPara xmlns:m="http://schemas.openxmlformats.org/officeDocument/2006/math">
                     <m:oMathParaPr>
@@ -27830,7 +27950,7 @@
             </p:txBody>
           </p:sp>
         </mc:Choice>
-        <mc:Fallback>
+        <mc:Fallback xmlns="">
           <p:sp>
             <p:nvSpPr>
               <p:cNvPr id="20" name="TextBox 19">
@@ -28241,8 +28361,8 @@
           </a:p>
         </p:txBody>
       </p:sp>
-      <mc:AlternateContent xmlns:mc="http://schemas.openxmlformats.org/markup-compatibility/2006">
-        <mc:Choice xmlns:a14="http://schemas.microsoft.com/office/drawing/2010/main" Requires="a14">
+      <mc:AlternateContent xmlns:mc="http://schemas.openxmlformats.org/markup-compatibility/2006" xmlns:a14="http://schemas.microsoft.com/office/drawing/2010/main">
+        <mc:Choice Requires="a14">
           <p:sp>
             <p:nvSpPr>
               <p:cNvPr id="17" name="TextBox 16">
@@ -28457,7 +28577,7 @@
             </p:txBody>
           </p:sp>
         </mc:Choice>
-        <mc:Fallback>
+        <mc:Fallback xmlns="">
           <p:sp>
             <p:nvSpPr>
               <p:cNvPr id="17" name="TextBox 16">
@@ -28502,8 +28622,8 @@
           </p:sp>
         </mc:Fallback>
       </mc:AlternateContent>
-      <mc:AlternateContent xmlns:mc="http://schemas.openxmlformats.org/markup-compatibility/2006">
-        <mc:Choice xmlns:a14="http://schemas.microsoft.com/office/drawing/2010/main" Requires="a14">
+      <mc:AlternateContent xmlns:mc="http://schemas.openxmlformats.org/markup-compatibility/2006" xmlns:a14="http://schemas.microsoft.com/office/drawing/2010/main">
+        <mc:Choice Requires="a14">
           <p:sp>
             <p:nvSpPr>
               <p:cNvPr id="18" name="TextBox 17">
@@ -28748,7 +28868,7 @@
             </p:txBody>
           </p:sp>
         </mc:Choice>
-        <mc:Fallback>
+        <mc:Fallback xmlns="">
           <p:sp>
             <p:nvSpPr>
               <p:cNvPr id="18" name="TextBox 17">
@@ -29668,8 +29788,8 @@
           </a:p>
         </p:txBody>
       </p:sp>
-      <mc:AlternateContent xmlns:mc="http://schemas.openxmlformats.org/markup-compatibility/2006">
-        <mc:Choice xmlns:a14="http://schemas.microsoft.com/office/drawing/2010/main" Requires="a14">
+      <mc:AlternateContent xmlns:mc="http://schemas.openxmlformats.org/markup-compatibility/2006" xmlns:a14="http://schemas.microsoft.com/office/drawing/2010/main">
+        <mc:Choice Requires="a14">
           <p:sp>
             <p:nvSpPr>
               <p:cNvPr id="15" name="TextBox 14">
@@ -29698,6 +29818,7 @@
               </a:bodyPr>
               <a:lstStyle/>
               <a:p>
+                <a:pPr/>
                 <a14:m>
                   <m:oMathPara xmlns:m="http://schemas.openxmlformats.org/officeDocument/2006/math">
                     <m:oMathParaPr>
@@ -29780,7 +29901,7 @@
             </p:txBody>
           </p:sp>
         </mc:Choice>
-        <mc:Fallback>
+        <mc:Fallback xmlns="">
           <p:sp>
             <p:nvSpPr>
               <p:cNvPr id="15" name="TextBox 14">
@@ -29825,8 +29946,8 @@
           </p:sp>
         </mc:Fallback>
       </mc:AlternateContent>
-      <mc:AlternateContent xmlns:mc="http://schemas.openxmlformats.org/markup-compatibility/2006">
-        <mc:Choice xmlns:a14="http://schemas.microsoft.com/office/drawing/2010/main" Requires="a14">
+      <mc:AlternateContent xmlns:mc="http://schemas.openxmlformats.org/markup-compatibility/2006" xmlns:a14="http://schemas.microsoft.com/office/drawing/2010/main">
+        <mc:Choice Requires="a14">
           <p:sp>
             <p:nvSpPr>
               <p:cNvPr id="16" name="TextBox 15">
@@ -29855,6 +29976,7 @@
               </a:bodyPr>
               <a:lstStyle/>
               <a:p>
+                <a:pPr/>
                 <a14:m>
                   <m:oMathPara xmlns:m="http://schemas.openxmlformats.org/officeDocument/2006/math">
                     <m:oMathParaPr>
@@ -30022,7 +30144,7 @@
             </p:txBody>
           </p:sp>
         </mc:Choice>
-        <mc:Fallback>
+        <mc:Fallback xmlns="">
           <p:sp>
             <p:nvSpPr>
               <p:cNvPr id="16" name="TextBox 15">
@@ -30231,8 +30353,8 @@
           </a:p>
         </p:txBody>
       </p:sp>
-      <mc:AlternateContent xmlns:mc="http://schemas.openxmlformats.org/markup-compatibility/2006">
-        <mc:Choice xmlns:a14="http://schemas.microsoft.com/office/drawing/2010/main" Requires="a14">
+      <mc:AlternateContent xmlns:mc="http://schemas.openxmlformats.org/markup-compatibility/2006" xmlns:a14="http://schemas.microsoft.com/office/drawing/2010/main">
+        <mc:Choice Requires="a14">
           <p:sp>
             <p:nvSpPr>
               <p:cNvPr id="27" name="TextBox 26">
@@ -30283,7 +30405,7 @@
             </p:txBody>
           </p:sp>
         </mc:Choice>
-        <mc:Fallback>
+        <mc:Fallback xmlns="">
           <p:sp>
             <p:nvSpPr>
               <p:cNvPr id="27" name="TextBox 26">
@@ -30372,8 +30494,8 @@
           </a:p>
         </p:txBody>
       </p:sp>
-      <mc:AlternateContent xmlns:mc="http://schemas.openxmlformats.org/markup-compatibility/2006">
-        <mc:Choice xmlns:a14="http://schemas.microsoft.com/office/drawing/2010/main" Requires="a14">
+      <mc:AlternateContent xmlns:mc="http://schemas.openxmlformats.org/markup-compatibility/2006" xmlns:a14="http://schemas.microsoft.com/office/drawing/2010/main">
+        <mc:Choice Requires="a14">
           <p:sp>
             <p:nvSpPr>
               <p:cNvPr id="31" name="TextBox 30">
@@ -30426,7 +30548,7 @@
             </p:txBody>
           </p:sp>
         </mc:Choice>
-        <mc:Fallback>
+        <mc:Fallback xmlns="">
           <p:sp>
             <p:nvSpPr>
               <p:cNvPr id="31" name="TextBox 30">
@@ -30471,8 +30593,8 @@
           </p:sp>
         </mc:Fallback>
       </mc:AlternateContent>
-      <mc:AlternateContent xmlns:mc="http://schemas.openxmlformats.org/markup-compatibility/2006">
-        <mc:Choice xmlns:a14="http://schemas.microsoft.com/office/drawing/2010/main" Requires="a14">
+      <mc:AlternateContent xmlns:mc="http://schemas.openxmlformats.org/markup-compatibility/2006" xmlns:a14="http://schemas.microsoft.com/office/drawing/2010/main">
+        <mc:Choice Requires="a14">
           <p:sp>
             <p:nvSpPr>
               <p:cNvPr id="37" name="TextBox 36">
@@ -30524,13 +30646,7 @@
                         <a:rPr lang="en-US" b="1" i="1" smtClean="0">
                           <a:latin typeface="Cambria Math" panose="02040503050406030204" pitchFamily="18" charset="0"/>
                         </a:rPr>
-                        <m:t>𝑨</m:t>
-                      </m:r>
-                      <m:r>
-                        <a:rPr lang="en-US" b="1" i="1" smtClean="0">
-                          <a:latin typeface="Cambria Math" panose="02040503050406030204" pitchFamily="18" charset="0"/>
-                        </a:rPr>
-                        <m:t>𝒑𝒆𝒓𝒕𝒖𝒓𝒆</m:t>
+                        <m:t>𝑨𝒑𝒆𝒓𝒕𝒖𝒓𝒆</m:t>
                       </m:r>
                     </m:oMath>
                   </m:oMathPara>
@@ -30540,7 +30656,7 @@
             </p:txBody>
           </p:sp>
         </mc:Choice>
-        <mc:Fallback>
+        <mc:Fallback xmlns="">
           <p:sp>
             <p:nvSpPr>
               <p:cNvPr id="37" name="TextBox 36">
@@ -30585,8 +30701,8 @@
           </p:sp>
         </mc:Fallback>
       </mc:AlternateContent>
-      <mc:AlternateContent xmlns:mc="http://schemas.openxmlformats.org/markup-compatibility/2006">
-        <mc:Choice xmlns:a14="http://schemas.microsoft.com/office/drawing/2010/main" Requires="a14">
+      <mc:AlternateContent xmlns:mc="http://schemas.openxmlformats.org/markup-compatibility/2006" xmlns:a14="http://schemas.microsoft.com/office/drawing/2010/main">
+        <mc:Choice Requires="a14">
           <p:sp>
             <p:nvSpPr>
               <p:cNvPr id="38" name="TextBox 37">
@@ -30615,6 +30731,7 @@
               </a:bodyPr>
               <a:lstStyle/>
               <a:p>
+                <a:pPr/>
                 <a14:m>
                   <m:oMathPara xmlns:m="http://schemas.openxmlformats.org/officeDocument/2006/math">
                     <m:oMathParaPr>
@@ -30711,7 +30828,7 @@
             </p:txBody>
           </p:sp>
         </mc:Choice>
-        <mc:Fallback>
+        <mc:Fallback xmlns="">
           <p:sp>
             <p:nvSpPr>
               <p:cNvPr id="38" name="TextBox 37">
@@ -31003,8 +31120,8 @@
           </a:fontRef>
         </p:style>
       </p:cxnSp>
-      <mc:AlternateContent xmlns:mc="http://schemas.openxmlformats.org/markup-compatibility/2006">
-        <mc:Choice xmlns:a14="http://schemas.microsoft.com/office/drawing/2010/main" Requires="a14">
+      <mc:AlternateContent xmlns:mc="http://schemas.openxmlformats.org/markup-compatibility/2006" xmlns:a14="http://schemas.microsoft.com/office/drawing/2010/main">
+        <mc:Choice Requires="a14">
           <p:sp>
             <p:nvSpPr>
               <p:cNvPr id="17" name="TextBox 16">
@@ -31219,7 +31336,7 @@
             </p:txBody>
           </p:sp>
         </mc:Choice>
-        <mc:Fallback>
+        <mc:Fallback xmlns="">
           <p:sp>
             <p:nvSpPr>
               <p:cNvPr id="17" name="TextBox 16">
@@ -31264,8 +31381,8 @@
           </p:sp>
         </mc:Fallback>
       </mc:AlternateContent>
-      <mc:AlternateContent xmlns:mc="http://schemas.openxmlformats.org/markup-compatibility/2006">
-        <mc:Choice xmlns:a14="http://schemas.microsoft.com/office/drawing/2010/main" Requires="a14">
+      <mc:AlternateContent xmlns:mc="http://schemas.openxmlformats.org/markup-compatibility/2006" xmlns:a14="http://schemas.microsoft.com/office/drawing/2010/main">
+        <mc:Choice Requires="a14">
           <p:sp>
             <p:nvSpPr>
               <p:cNvPr id="18" name="TextBox 17">
@@ -31510,7 +31627,7 @@
             </p:txBody>
           </p:sp>
         </mc:Choice>
-        <mc:Fallback>
+        <mc:Fallback xmlns="">
           <p:sp>
             <p:nvSpPr>
               <p:cNvPr id="18" name="TextBox 17">
@@ -32130,8 +32247,8 @@
           </a:fontRef>
         </p:style>
       </p:cxnSp>
-      <mc:AlternateContent xmlns:mc="http://schemas.openxmlformats.org/markup-compatibility/2006">
-        <mc:Choice xmlns:a14="http://schemas.microsoft.com/office/drawing/2010/main" Requires="a14">
+      <mc:AlternateContent xmlns:mc="http://schemas.openxmlformats.org/markup-compatibility/2006" xmlns:a14="http://schemas.microsoft.com/office/drawing/2010/main">
+        <mc:Choice Requires="a14">
           <p:sp>
             <p:nvSpPr>
               <p:cNvPr id="67" name="TextBox 66">
@@ -32343,7 +32460,7 @@
             </p:txBody>
           </p:sp>
         </mc:Choice>
-        <mc:Fallback>
+        <mc:Fallback xmlns="">
           <p:sp>
             <p:nvSpPr>
               <p:cNvPr id="67" name="TextBox 66">
@@ -32388,8 +32505,8 @@
           </p:sp>
         </mc:Fallback>
       </mc:AlternateContent>
-      <mc:AlternateContent xmlns:mc="http://schemas.openxmlformats.org/markup-compatibility/2006">
-        <mc:Choice xmlns:a14="http://schemas.microsoft.com/office/drawing/2010/main" Requires="a14">
+      <mc:AlternateContent xmlns:mc="http://schemas.openxmlformats.org/markup-compatibility/2006" xmlns:a14="http://schemas.microsoft.com/office/drawing/2010/main">
+        <mc:Choice Requires="a14">
           <p:sp>
             <p:nvSpPr>
               <p:cNvPr id="68" name="TextBox 67">
@@ -32667,7 +32784,7 @@
             </p:txBody>
           </p:sp>
         </mc:Choice>
-        <mc:Fallback>
+        <mc:Fallback xmlns="">
           <p:sp>
             <p:nvSpPr>
               <p:cNvPr id="68" name="TextBox 67">
@@ -34107,8 +34224,8 @@
           </a:fontRef>
         </p:style>
       </p:cxnSp>
-      <mc:AlternateContent xmlns:mc="http://schemas.openxmlformats.org/markup-compatibility/2006">
-        <mc:Choice xmlns:a14="http://schemas.microsoft.com/office/drawing/2010/main" Requires="a14">
+      <mc:AlternateContent xmlns:mc="http://schemas.openxmlformats.org/markup-compatibility/2006" xmlns:a14="http://schemas.microsoft.com/office/drawing/2010/main">
+        <mc:Choice Requires="a14">
           <p:sp>
             <p:nvSpPr>
               <p:cNvPr id="15" name="TextBox 14">
@@ -34137,6 +34254,7 @@
               </a:bodyPr>
               <a:lstStyle/>
               <a:p>
+                <a:pPr/>
                 <a14:m>
                   <m:oMathPara xmlns:m="http://schemas.openxmlformats.org/officeDocument/2006/math">
                     <m:oMathParaPr>
@@ -34175,7 +34293,7 @@
             </p:txBody>
           </p:sp>
         </mc:Choice>
-        <mc:Fallback>
+        <mc:Fallback xmlns="">
           <p:sp>
             <p:nvSpPr>
               <p:cNvPr id="15" name="TextBox 14">
@@ -34220,8 +34338,8 @@
           </p:sp>
         </mc:Fallback>
       </mc:AlternateContent>
-      <mc:AlternateContent xmlns:mc="http://schemas.openxmlformats.org/markup-compatibility/2006">
-        <mc:Choice xmlns:a14="http://schemas.microsoft.com/office/drawing/2010/main" Requires="a14">
+      <mc:AlternateContent xmlns:mc="http://schemas.openxmlformats.org/markup-compatibility/2006" xmlns:a14="http://schemas.microsoft.com/office/drawing/2010/main">
+        <mc:Choice Requires="a14">
           <p:sp>
             <p:nvSpPr>
               <p:cNvPr id="16" name="TextBox 15">
@@ -34250,6 +34368,7 @@
               </a:bodyPr>
               <a:lstStyle/>
               <a:p>
+                <a:pPr/>
                 <a14:m>
                   <m:oMathPara xmlns:m="http://schemas.openxmlformats.org/officeDocument/2006/math">
                     <m:oMathParaPr>
@@ -34288,7 +34407,7 @@
             </p:txBody>
           </p:sp>
         </mc:Choice>
-        <mc:Fallback>
+        <mc:Fallback xmlns="">
           <p:sp>
             <p:nvSpPr>
               <p:cNvPr id="16" name="TextBox 15">
@@ -34333,8 +34452,8 @@
           </p:sp>
         </mc:Fallback>
       </mc:AlternateContent>
-      <mc:AlternateContent xmlns:mc="http://schemas.openxmlformats.org/markup-compatibility/2006">
-        <mc:Choice xmlns:a14="http://schemas.microsoft.com/office/drawing/2010/main" Requires="a14">
+      <mc:AlternateContent xmlns:mc="http://schemas.openxmlformats.org/markup-compatibility/2006" xmlns:a14="http://schemas.microsoft.com/office/drawing/2010/main">
+        <mc:Choice Requires="a14">
           <p:sp>
             <p:nvSpPr>
               <p:cNvPr id="19" name="TextBox 18">
@@ -34363,6 +34482,7 @@
               </a:bodyPr>
               <a:lstStyle/>
               <a:p>
+                <a:pPr/>
                 <a14:m>
                   <m:oMathPara xmlns:m="http://schemas.openxmlformats.org/officeDocument/2006/math">
                     <m:oMathParaPr>
@@ -34401,7 +34521,7 @@
             </p:txBody>
           </p:sp>
         </mc:Choice>
-        <mc:Fallback>
+        <mc:Fallback xmlns="">
           <p:sp>
             <p:nvSpPr>
               <p:cNvPr id="19" name="TextBox 18">

</xml_diff>